<commit_message>
Refresh doc artifacts: per-path runbook PDFs, deck with executed-replica proof
- runbook-zero-copy.pdf + runbook-s3-replica.pdf replace the stale unified
  runbook.pdf
- deck appendix slide D: three new sharp edges from the executed replica run
  + the identical-results proof (4 rows / 467.75 on both paths)

Co-Authored-By: Claude Fable 5 <noreply@anthropic.com>
</commit_message>
<xml_diff>
--- a/docs/iceberg-zero-copy-approach.pptx
+++ b/docs/iceberg-zero-copy-approach.pptx
@@ -1045,7 +1045,7 @@
           <a:p>
             <a:r>
               <a:rPr lang="en-US" dirty="0"/>
-              <a:t>Built and executed 2026-07-16 against a personal AWS free-plan account — pennies of spend.</a:t>
+              <a:t>Executed against a personal AWS free-plan account — pennies of spend. The identical-results query is the closing proof for the trade-offs slide.</a:t>
             </a:r>
             <a:endParaRPr lang="en-US" dirty="0"/>
           </a:p>
@@ -7191,7 +7191,7 @@
                 <a:ea typeface="Calibri" pitchFamily="34" charset="-122"/>
                 <a:cs typeface="Calibri" pitchFamily="34" charset="-120"/>
               </a:rPr>
-              <a:t>CREATE OR REPLACE EXTERNAL VOLUME mints a new external id — redo trust</a:t>
+              <a:t>Hyphenated catalog names must be backtick-quoted in Spark CALL</a:t>
             </a:r>
             <a:endParaRPr lang="en-US" sz="1050" dirty="0"/>
           </a:p>
@@ -7212,7 +7212,7 @@
                 <a:ea typeface="Calibri" pitchFamily="34" charset="-122"/>
                 <a:cs typeface="Calibri" pitchFamily="34" charset="-120"/>
               </a:rPr>
-              <a:t>Replica staleness is by design — it's the break-even trade</a:t>
+              <a:t>Staging must live INSIDE the table location — vended credentials are table-prefix-scoped</a:t>
             </a:r>
             <a:endParaRPr lang="en-US" sz="1050" dirty="0"/>
           </a:p>
@@ -7233,7 +7233,28 @@
                 <a:ea typeface="Calibri" pitchFamily="34" charset="-122"/>
                 <a:cs typeface="Calibri" pitchFamily="34" charset="-120"/>
               </a:rPr>
-              <a:t>Match bucket region to the Snowflake account region</a:t>
+              <a:t>The rewrite copy plan is a Spark output directory of part-files</a:t>
+            </a:r>
+            <a:endParaRPr lang="en-US" sz="1050" dirty="0"/>
+          </a:p>
+          <a:p>
+            <a:pPr marL="342900" indent="-342900">
+              <a:spcAft>
+                <a:spcPts val="800"/>
+              </a:spcAft>
+              <a:buSzPct val="100000"/>
+              <a:buChar char="•"/>
+            </a:pPr>
+            <a:r>
+              <a:rPr lang="en-US" sz="1050" dirty="0">
+                <a:solidFill>
+                  <a:srgbClr val="33475B"/>
+                </a:solidFill>
+                <a:latin typeface="Calibri" pitchFamily="34" charset="0"/>
+                <a:ea typeface="Calibri" pitchFamily="34" charset="-122"/>
+                <a:cs typeface="Calibri" pitchFamily="34" charset="-120"/>
+              </a:rPr>
+              <a:t>CREATE OR REPLACE EXTERNAL VOLUME mints a new external id — redo trust</a:t>
             </a:r>
             <a:endParaRPr lang="en-US" sz="1050" dirty="0"/>
           </a:p>
@@ -7272,7 +7293,7 @@
                 <a:ea typeface="Calibri" pitchFamily="34" charset="-122"/>
                 <a:cs typeface="Calibri" pitchFamily="34" charset="-120"/>
               </a:rPr>
-              <a:t>Full detail: docs/runbook-s3-replica.md. Both trust models keyless and revocable in one line.</a:t>
+              <a:t>Executed 2026-07-16: both paths returned identical results from Snowflake (4 rows, 467.75). Full detail: docs/runbook-s3-replica.md.</a:t>
             </a:r>
             <a:endParaRPr lang="en-US" sz="1100" dirty="0"/>
           </a:p>

</xml_diff>

<commit_message>
Approach deck: appendix runbook now pairs code + proof per step
Restructure the appendix from separate runbook-text and snapshot slides into
one slide per runbook step, each showing the actual code block beside its
matching screenshot: catalog+storage, write-table (Spark), keyless trust
(WIF), catalog integration, linked DB + read. Adds a standalone sharp-edges
slide. 19 slides total.

Co-Authored-By: Claude Fable 5 <noreply@anthropic.com>
</commit_message>
<xml_diff>
--- a/docs/iceberg-zero-copy-approach.pptx
+++ b/docs/iceberg-zero-copy-approach.pptx
@@ -22,9 +22,11 @@
     <p:sldId id="270" r:id="rId16"/>
     <p:sldId id="271" r:id="rId17"/>
     <p:sldId id="272" r:id="rId18"/>
+    <p:sldId id="273" r:id="rId19"/>
+    <p:sldId id="274" r:id="rId20"/>
   </p:sldIdLst>
   <p:notesMasterIdLst>
-    <p:notesMasterId r:id="rId19"/>
+    <p:notesMasterId r:id="rId21"/>
   </p:notesMasterIdLst>
   <p:sldSz cx="12192000" cy="6858000"/>
   <p:notesSz cx="6858000" cy="12192000"/>
@@ -1246,6 +1248,182 @@
             <a:fld id="{F7021451-1387-4CA6-816F-3879F97B5CBC}" type="slidenum">
               <a:rPr lang="en-US"/>
               <a:t>17</a:t>
+            </a:fld>
+            <a:endParaRPr lang="en-US"/>
+          </a:p>
+        </p:txBody>
+      </p:sp>
+    </p:spTree>
+    <p:extLst>
+      <p:ext uri="{BB962C8B-B14F-4D97-AF65-F5344CB8AC3E}">
+        <p14:creationId xmlns:p14="http://schemas.microsoft.com/office/powerpoint/2010/main" val="1024086991"/>
+      </p:ext>
+    </p:extLst>
+  </p:cSld>
+  <p:clrMapOvr>
+    <a:masterClrMapping/>
+  </p:clrMapOvr>
+</p:notes>
+</file>
+
+<file path=ppt/notesSlides/notesSlide18.xml><?xml version="1.0" encoding="utf-8"?>
+<p:notes xmlns:a="http://schemas.openxmlformats.org/drawingml/2006/main" xmlns:r="http://schemas.openxmlformats.org/officeDocument/2006/relationships" xmlns:p="http://schemas.openxmlformats.org/presentationml/2006/main">
+  <p:cSld>
+    <p:spTree>
+      <p:nvGrpSpPr>
+        <p:cNvPr id="1" name=""/>
+        <p:cNvGrpSpPr/>
+        <p:nvPr/>
+      </p:nvGrpSpPr>
+      <p:grpSpPr>
+        <a:xfrm>
+          <a:off x="0" y="0"/>
+          <a:ext cx="0" cy="0"/>
+          <a:chOff x="0" y="0"/>
+          <a:chExt cx="0" cy="0"/>
+        </a:xfrm>
+      </p:grpSpPr>
+      <p:sp>
+        <p:nvSpPr>
+          <p:cNvPr id="2" name="Slide Image Placeholder 1"/>
+          <p:cNvSpPr>
+            <a:spLocks noGrp="1" noRot="1" noChangeAspect="1"/>
+          </p:cNvSpPr>
+          <p:nvPr>
+            <p:ph type="sldImg"/>
+          </p:nvPr>
+        </p:nvSpPr>
+        <p:spPr/>
+      </p:sp>
+      <p:sp>
+        <p:nvSpPr>
+          <p:cNvPr id="3" name="Notes Placeholder 2"/>
+          <p:cNvSpPr>
+            <a:spLocks noGrp="1"/>
+          </p:cNvSpPr>
+          <p:nvPr>
+            <p:ph type="body" idx="1"/>
+          </p:nvPr>
+        </p:nvSpPr>
+        <p:spPr/>
+        <p:txBody>
+          <a:bodyPr/>
+          <a:lstStyle/>
+          <a:p>
+            <a:r>
+              <a:rPr lang="en-US" dirty="0"/>
+              <a:t/>
+            </a:r>
+            <a:endParaRPr lang="en-US" dirty="0"/>
+          </a:p>
+        </p:txBody>
+      </p:sp>
+      <p:sp>
+        <p:nvSpPr>
+          <p:cNvPr id="4" name="Slide Number Placeholder 3"/>
+          <p:cNvSpPr>
+            <a:spLocks noGrp="1"/>
+          </p:cNvSpPr>
+          <p:nvPr>
+            <p:ph type="sldNum" sz="quarter" idx="10"/>
+          </p:nvPr>
+        </p:nvSpPr>
+        <p:spPr/>
+        <p:txBody>
+          <a:bodyPr/>
+          <a:lstStyle/>
+          <a:p>
+            <a:fld id="{F7021451-1387-4CA6-816F-3879F97B5CBC}" type="slidenum">
+              <a:rPr lang="en-US"/>
+              <a:t>18</a:t>
+            </a:fld>
+            <a:endParaRPr lang="en-US"/>
+          </a:p>
+        </p:txBody>
+      </p:sp>
+    </p:spTree>
+    <p:extLst>
+      <p:ext uri="{BB962C8B-B14F-4D97-AF65-F5344CB8AC3E}">
+        <p14:creationId xmlns:p14="http://schemas.microsoft.com/office/powerpoint/2010/main" val="1024086991"/>
+      </p:ext>
+    </p:extLst>
+  </p:cSld>
+  <p:clrMapOvr>
+    <a:masterClrMapping/>
+  </p:clrMapOvr>
+</p:notes>
+</file>
+
+<file path=ppt/notesSlides/notesSlide19.xml><?xml version="1.0" encoding="utf-8"?>
+<p:notes xmlns:a="http://schemas.openxmlformats.org/drawingml/2006/main" xmlns:r="http://schemas.openxmlformats.org/officeDocument/2006/relationships" xmlns:p="http://schemas.openxmlformats.org/presentationml/2006/main">
+  <p:cSld>
+    <p:spTree>
+      <p:nvGrpSpPr>
+        <p:cNvPr id="1" name=""/>
+        <p:cNvGrpSpPr/>
+        <p:nvPr/>
+      </p:nvGrpSpPr>
+      <p:grpSpPr>
+        <a:xfrm>
+          <a:off x="0" y="0"/>
+          <a:ext cx="0" cy="0"/>
+          <a:chOff x="0" y="0"/>
+          <a:chExt cx="0" cy="0"/>
+        </a:xfrm>
+      </p:grpSpPr>
+      <p:sp>
+        <p:nvSpPr>
+          <p:cNvPr id="2" name="Slide Image Placeholder 1"/>
+          <p:cNvSpPr>
+            <a:spLocks noGrp="1" noRot="1" noChangeAspect="1"/>
+          </p:cNvSpPr>
+          <p:nvPr>
+            <p:ph type="sldImg"/>
+          </p:nvPr>
+        </p:nvSpPr>
+        <p:spPr/>
+      </p:sp>
+      <p:sp>
+        <p:nvSpPr>
+          <p:cNvPr id="3" name="Notes Placeholder 2"/>
+          <p:cNvSpPr>
+            <a:spLocks noGrp="1"/>
+          </p:cNvSpPr>
+          <p:nvPr>
+            <p:ph type="body" idx="1"/>
+          </p:nvPr>
+        </p:nvSpPr>
+        <p:spPr/>
+        <p:txBody>
+          <a:bodyPr/>
+          <a:lstStyle/>
+          <a:p>
+            <a:r>
+              <a:rPr lang="en-US" dirty="0"/>
+              <a:t/>
+            </a:r>
+            <a:endParaRPr lang="en-US" dirty="0"/>
+          </a:p>
+        </p:txBody>
+      </p:sp>
+      <p:sp>
+        <p:nvSpPr>
+          <p:cNvPr id="4" name="Slide Number Placeholder 3"/>
+          <p:cNvSpPr>
+            <a:spLocks noGrp="1"/>
+          </p:cNvSpPr>
+          <p:nvPr>
+            <p:ph type="sldNum" sz="quarter" idx="10"/>
+          </p:nvPr>
+        </p:nvSpPr>
+        <p:spPr/>
+        <p:txBody>
+          <a:bodyPr/>
+          <a:lstStyle/>
+          <a:p>
+            <a:fld id="{F7021451-1387-4CA6-816F-3879F97B5CBC}" type="slidenum">
+              <a:rPr lang="en-US"/>
+              <a:t>19</a:t>
             </a:fld>
             <a:endParaRPr lang="en-US"/>
           </a:p>
@@ -4612,7 +4790,7 @@
                 <a:ea typeface="Cambria" pitchFamily="34" charset="-122"/>
                 <a:cs typeface="Cambria" pitchFamily="34" charset="-120"/>
               </a:rPr>
-              <a:t>APPENDIX — RUNBOOK &amp; PROOF</a:t>
+              <a:t>APPENDIX — RUNBOOK: CODE &amp; PROOF</a:t>
             </a:r>
             <a:endParaRPr lang="en-US" sz="4200" dirty="0"/>
           </a:p>
@@ -4683,7 +4861,7 @@
                 <a:ea typeface="Cambria" pitchFamily="34" charset="-122"/>
                 <a:cs typeface="Cambria" pitchFamily="34" charset="-120"/>
               </a:rPr>
-              <a:t>Appendix A — Runbook (Zero-Copy Federation)</a:t>
+              <a:t>Appendix  ·  Step 1 of 5 — Catalog + Storage</a:t>
             </a:r>
             <a:endParaRPr lang="en-US" sz="2800" dirty="0"/>
           </a:p>
@@ -4722,7 +4900,7 @@
                 <a:ea typeface="Calibri" pitchFamily="34" charset="-122"/>
                 <a:cs typeface="Calibri" pitchFamily="34" charset="-120"/>
               </a:rPr>
-              <a:t>The build, condensed; sharp edges on the right</a:t>
+              <a:t>Enable the API, make the bucket, register a REST catalog with credential vending</a:t>
             </a:r>
             <a:endParaRPr lang="en-US" sz="1400" dirty="0"/>
           </a:p>
@@ -4775,18 +4953,20 @@
         </p:nvSpPr>
         <p:spPr>
           <a:xfrm>
-            <a:off x="594360" y="1307592"/>
-            <a:ext cx="384048" cy="384048"/>
-          </a:xfrm>
-          <a:prstGeom prst="ellipse">
-            <a:avLst/>
+            <a:off x="548640" y="1371600"/>
+            <a:ext cx="5623560" cy="4297680"/>
+          </a:xfrm>
+          <a:prstGeom prst="roundRect">
+            <a:avLst>
+              <a:gd name="adj" fmla="val 1064"/>
+            </a:avLst>
           </a:prstGeom>
           <a:solidFill>
-            <a:srgbClr val="0F5C56"/>
+            <a:srgbClr val="0E2A2A"/>
           </a:solidFill>
           <a:ln w="12700">
             <a:solidFill>
-              <a:srgbClr val="0F5C56"/>
+              <a:srgbClr val="0E2A2A"/>
             </a:solidFill>
             <a:prstDash val="solid"/>
           </a:ln>
@@ -4800,47 +4980,8 @@
         </p:nvSpPr>
         <p:spPr>
           <a:xfrm>
-            <a:off x="594360" y="1307592"/>
-            <a:ext cx="384048" cy="384048"/>
-          </a:xfrm>
-          <a:prstGeom prst="rect">
-            <a:avLst/>
-          </a:prstGeom>
-          <a:noFill/>
-          <a:ln/>
-        </p:spPr>
-        <p:txBody>
-          <a:bodyPr wrap="square" lIns="0" tIns="0" rIns="0" bIns="0" rtlCol="0" anchor="ctr"/>
-          <a:lstStyle/>
-          <a:p>
-            <a:pPr algn="ctr" indent="0" marL="0">
-              <a:buNone/>
-            </a:pPr>
-            <a:r>
-              <a:rPr lang="en-US" sz="1300" b="1" dirty="0">
-                <a:solidFill>
-                  <a:srgbClr val="FFFFFF"/>
-                </a:solidFill>
-                <a:latin typeface="Cambria" pitchFamily="34" charset="0"/>
-                <a:ea typeface="Cambria" pitchFamily="34" charset="-122"/>
-                <a:cs typeface="Cambria" pitchFamily="34" charset="-120"/>
-              </a:rPr>
-              <a:t>1</a:t>
-            </a:r>
-            <a:endParaRPr lang="en-US" sz="1300" dirty="0"/>
-          </a:p>
-        </p:txBody>
-      </p:sp>
-      <p:sp>
-        <p:nvSpPr>
-          <p:cNvPr id="7" name="Text 5"/>
-          <p:cNvSpPr/>
-          <p:nvPr/>
-        </p:nvSpPr>
-        <p:spPr>
-          <a:xfrm>
-            <a:off x="1143000" y="1261872"/>
-            <a:ext cx="6126480" cy="713232"/>
+            <a:off x="713232" y="1499616"/>
+            <a:ext cx="5294376" cy="4041648"/>
           </a:xfrm>
           <a:prstGeom prst="rect">
             <a:avLst/>
@@ -4852,735 +4993,314 @@
           <a:bodyPr wrap="square" lIns="0" tIns="0" rIns="0" bIns="0" rtlCol="0" anchor="t"/>
           <a:lstStyle/>
           <a:p>
+            <a:pPr algn="l" indent="0" marL="0">
+              <a:lnSpc>
+                <a:spcPct val="105000"/>
+              </a:lnSpc>
+              <a:buNone/>
+            </a:pPr>
+            <a:r>
+              <a:rPr lang="en-US" sz="950" dirty="0">
+                <a:solidFill>
+                  <a:srgbClr val="CFE8E6"/>
+                </a:solidFill>
+                <a:latin typeface="Courier New" pitchFamily="34" charset="0"/>
+                <a:ea typeface="Courier New" pitchFamily="34" charset="-122"/>
+                <a:cs typeface="Courier New" pitchFamily="34" charset="-120"/>
+              </a:rPr>
+              <a:t># enable API, make the bucket,</a:t>
+            </a:r>
+            <a:endParaRPr lang="en-US" sz="950" dirty="0"/>
+          </a:p>
+          <a:p>
+            <a:pPr algn="l" indent="0" marL="0">
+              <a:lnSpc>
+                <a:spcPct val="105000"/>
+              </a:lnSpc>
+              <a:buNone/>
+            </a:pPr>
+            <a:r>
+              <a:rPr lang="en-US" sz="950" dirty="0">
+                <a:solidFill>
+                  <a:srgbClr val="CFE8E6"/>
+                </a:solidFill>
+                <a:latin typeface="Courier New" pitchFamily="34" charset="0"/>
+                <a:ea typeface="Courier New" pitchFamily="34" charset="-122"/>
+                <a:cs typeface="Courier New" pitchFamily="34" charset="-120"/>
+              </a:rPr>
+              <a:t># register the REST catalog</a:t>
+            </a:r>
+            <a:endParaRPr lang="en-US" sz="950" dirty="0"/>
+          </a:p>
+          <a:p>
+            <a:pPr algn="l" indent="0" marL="0">
+              <a:lnSpc>
+                <a:spcPct val="105000"/>
+              </a:lnSpc>
+              <a:buNone/>
+            </a:pPr>
+            <a:r>
+              <a:rPr lang="en-US" sz="950" dirty="0">
+                <a:solidFill>
+                  <a:srgbClr val="CFE8E6"/>
+                </a:solidFill>
+                <a:latin typeface="Courier New" pitchFamily="34" charset="0"/>
+                <a:ea typeface="Courier New" pitchFamily="34" charset="-122"/>
+                <a:cs typeface="Courier New" pitchFamily="34" charset="-120"/>
+              </a:rPr>
+              <a:t>gcloud services enable \</a:t>
+            </a:r>
+            <a:endParaRPr lang="en-US" sz="950" dirty="0"/>
+          </a:p>
+          <a:p>
+            <a:pPr algn="l" indent="0" marL="0">
+              <a:lnSpc>
+                <a:spcPct val="105000"/>
+              </a:lnSpc>
+              <a:buNone/>
+            </a:pPr>
+            <a:r>
+              <a:rPr lang="en-US" sz="950" dirty="0">
+                <a:solidFill>
+                  <a:srgbClr val="CFE8E6"/>
+                </a:solidFill>
+                <a:latin typeface="Courier New" pitchFamily="34" charset="0"/>
+                <a:ea typeface="Courier New" pitchFamily="34" charset="-122"/>
+                <a:cs typeface="Courier New" pitchFamily="34" charset="-120"/>
+              </a:rPr>
+              <a:t>  biglake.googleapis.com</a:t>
+            </a:r>
+            <a:endParaRPr lang="en-US" sz="950" dirty="0"/>
+          </a:p>
+          <a:p>
+            <a:pPr algn="l" indent="0" marL="0">
+              <a:lnSpc>
+                <a:spcPct val="105000"/>
+              </a:lnSpc>
+              <a:buNone/>
+            </a:pPr>
+            <a:endParaRPr lang="en-US" sz="950" dirty="0"/>
+          </a:p>
+          <a:p>
+            <a:pPr algn="l" indent="0" marL="0">
+              <a:lnSpc>
+                <a:spcPct val="105000"/>
+              </a:lnSpc>
+              <a:buNone/>
+            </a:pPr>
+            <a:r>
+              <a:rPr lang="en-US" sz="950" dirty="0">
+                <a:solidFill>
+                  <a:srgbClr val="CFE8E6"/>
+                </a:solidFill>
+                <a:latin typeface="Courier New" pitchFamily="34" charset="0"/>
+                <a:ea typeface="Courier New" pitchFamily="34" charset="-122"/>
+                <a:cs typeface="Courier New" pitchFamily="34" charset="-120"/>
+              </a:rPr>
+              <a:t>gsutil mb -l $REGION gs://$BUCKET</a:t>
+            </a:r>
+            <a:endParaRPr lang="en-US" sz="950" dirty="0"/>
+          </a:p>
+          <a:p>
+            <a:pPr algn="l" indent="0" marL="0">
+              <a:lnSpc>
+                <a:spcPct val="105000"/>
+              </a:lnSpc>
+              <a:buNone/>
+            </a:pPr>
+            <a:endParaRPr lang="en-US" sz="950" dirty="0"/>
+          </a:p>
+          <a:p>
+            <a:pPr algn="l" indent="0" marL="0">
+              <a:lnSpc>
+                <a:spcPct val="105000"/>
+              </a:lnSpc>
+              <a:buNone/>
+            </a:pPr>
+            <a:r>
+              <a:rPr lang="en-US" sz="950" dirty="0">
+                <a:solidFill>
+                  <a:srgbClr val="CFE8E6"/>
+                </a:solidFill>
+                <a:latin typeface="Courier New" pitchFamily="34" charset="0"/>
+                <a:ea typeface="Courier New" pitchFamily="34" charset="-122"/>
+                <a:cs typeface="Courier New" pitchFamily="34" charset="-120"/>
+              </a:rPr>
+              <a:t>gcloud biglake iceberg catalogs \</a:t>
+            </a:r>
+            <a:endParaRPr lang="en-US" sz="950" dirty="0"/>
+          </a:p>
+          <a:p>
+            <a:pPr algn="l" indent="0" marL="0">
+              <a:lnSpc>
+                <a:spcPct val="105000"/>
+              </a:lnSpc>
+              <a:buNone/>
+            </a:pPr>
+            <a:r>
+              <a:rPr lang="en-US" sz="950" dirty="0">
+                <a:solidFill>
+                  <a:srgbClr val="CFE8E6"/>
+                </a:solidFill>
+                <a:latin typeface="Courier New" pitchFamily="34" charset="0"/>
+                <a:ea typeface="Courier New" pitchFamily="34" charset="-122"/>
+                <a:cs typeface="Courier New" pitchFamily="34" charset="-120"/>
+              </a:rPr>
+              <a:t>  create $BUCKET \</a:t>
+            </a:r>
+            <a:endParaRPr lang="en-US" sz="950" dirty="0"/>
+          </a:p>
+          <a:p>
+            <a:pPr algn="l" indent="0" marL="0">
+              <a:lnSpc>
+                <a:spcPct val="105000"/>
+              </a:lnSpc>
+              <a:buNone/>
+            </a:pPr>
+            <a:r>
+              <a:rPr lang="en-US" sz="950" dirty="0">
+                <a:solidFill>
+                  <a:srgbClr val="CFE8E6"/>
+                </a:solidFill>
+                <a:latin typeface="Courier New" pitchFamily="34" charset="0"/>
+                <a:ea typeface="Courier New" pitchFamily="34" charset="-122"/>
+                <a:cs typeface="Courier New" pitchFamily="34" charset="-120"/>
+              </a:rPr>
+              <a:t>  --catalog-type gcs-bucket \</a:t>
+            </a:r>
+            <a:endParaRPr lang="en-US" sz="950" dirty="0"/>
+          </a:p>
+          <a:p>
+            <a:pPr algn="l" indent="0" marL="0">
+              <a:lnSpc>
+                <a:spcPct val="105000"/>
+              </a:lnSpc>
+              <a:buNone/>
+            </a:pPr>
+            <a:r>
+              <a:rPr lang="en-US" sz="950" dirty="0">
+                <a:solidFill>
+                  <a:srgbClr val="CFE8E6"/>
+                </a:solidFill>
+                <a:latin typeface="Courier New" pitchFamily="34" charset="0"/>
+                <a:ea typeface="Courier New" pitchFamily="34" charset="-122"/>
+                <a:cs typeface="Courier New" pitchFamily="34" charset="-120"/>
+              </a:rPr>
+              <a:t>  --credential-mode vended-credentials</a:t>
+            </a:r>
+            <a:endParaRPr lang="en-US" sz="950" dirty="0"/>
+          </a:p>
+          <a:p>
+            <a:pPr algn="l" indent="0" marL="0">
+              <a:lnSpc>
+                <a:spcPct val="105000"/>
+              </a:lnSpc>
+              <a:buNone/>
+            </a:pPr>
+            <a:endParaRPr lang="en-US" sz="950" dirty="0"/>
+          </a:p>
+          <a:p>
+            <a:pPr algn="l" indent="0" marL="0">
+              <a:lnSpc>
+                <a:spcPct val="105000"/>
+              </a:lnSpc>
+              <a:buNone/>
+            </a:pPr>
+            <a:r>
+              <a:rPr lang="en-US" sz="950" dirty="0">
+                <a:solidFill>
+                  <a:srgbClr val="CFE8E6"/>
+                </a:solidFill>
+                <a:latin typeface="Courier New" pitchFamily="34" charset="0"/>
+                <a:ea typeface="Courier New" pitchFamily="34" charset="-122"/>
+                <a:cs typeface="Courier New" pitchFamily="34" charset="-120"/>
+              </a:rPr>
+              <a:t># then grant the catalog runtime SA</a:t>
+            </a:r>
+            <a:endParaRPr lang="en-US" sz="950" dirty="0"/>
+          </a:p>
+          <a:p>
+            <a:pPr algn="l" indent="0" marL="0">
+              <a:lnSpc>
+                <a:spcPct val="105000"/>
+              </a:lnSpc>
+              <a:buNone/>
+            </a:pPr>
+            <a:r>
+              <a:rPr lang="en-US" sz="950" dirty="0">
+                <a:solidFill>
+                  <a:srgbClr val="CFE8E6"/>
+                </a:solidFill>
+                <a:latin typeface="Courier New" pitchFamily="34" charset="0"/>
+                <a:ea typeface="Courier New" pitchFamily="34" charset="-122"/>
+                <a:cs typeface="Courier New" pitchFamily="34" charset="-120"/>
+              </a:rPr>
+              <a:t># storage.objectUser on the bucket</a:t>
+            </a:r>
+            <a:endParaRPr lang="en-US" sz="950" dirty="0"/>
+          </a:p>
+        </p:txBody>
+      </p:sp>
+      <p:pic>
+        <p:nvPicPr>
+          <p:cNvPr id="7" name="Image 0" descr="C:/Users/jerem/AppData/Local/Temp/claude/C--claude/ae2a9827-8b94-4dcd-a82b-a6eb63227025/scratchpad/redacted-gcs_bucket_for__iceberg.png">    </p:cNvPr>
+          <p:cNvPicPr>
+            <a:picLocks noChangeAspect="1"/>
+          </p:cNvPicPr>
+          <p:nvPr/>
+        </p:nvPicPr>
+        <p:blipFill>
+          <a:blip r:embed="rId1"/>
+          <a:stretch>
+            <a:fillRect/>
+          </a:stretch>
+        </p:blipFill>
+        <p:spPr>
+          <a:xfrm>
+            <a:off x="6355080" y="3064653"/>
+            <a:ext cx="5394960" cy="180054"/>
+          </a:xfrm>
+          <a:prstGeom prst="rect">
+            <a:avLst/>
+          </a:prstGeom>
+        </p:spPr>
+      </p:pic>
+      <p:sp>
+        <p:nvSpPr>
+          <p:cNvPr id="8" name="Text 5"/>
+          <p:cNvSpPr/>
+          <p:nvPr/>
+        </p:nvSpPr>
+        <p:spPr>
+          <a:xfrm>
+            <a:off x="6355080" y="5074920"/>
+            <a:ext cx="5349240" cy="685800"/>
+          </a:xfrm>
+          <a:prstGeom prst="rect">
+            <a:avLst/>
+          </a:prstGeom>
+          <a:noFill/>
+          <a:ln/>
+        </p:spPr>
+        <p:txBody>
+          <a:bodyPr wrap="square" lIns="0" tIns="0" rIns="0" bIns="0" rtlCol="0" anchor="t"/>
+          <a:lstStyle/>
+          <a:p>
             <a:pPr indent="0" marL="0">
               <a:buNone/>
             </a:pPr>
             <a:r>
-              <a:rPr lang="en-US" sz="1150" b="1" dirty="0">
-                <a:solidFill>
-                  <a:srgbClr val="0B3D3D"/>
-                </a:solidFill>
-                <a:latin typeface="Calibri" pitchFamily="34" charset="0"/>
-                <a:ea typeface="Calibri" pitchFamily="34" charset="-122"/>
-                <a:cs typeface="Calibri" pitchFamily="34" charset="-120"/>
-              </a:rPr>
-              <a:t>Catalog + storage   </a:t>
-            </a:r>
-            <a:pPr indent="0" marL="0">
-              <a:buNone/>
-            </a:pPr>
-            <a:r>
-              <a:rPr lang="en-US" sz="1150" dirty="0">
-                <a:solidFill>
-                  <a:srgbClr val="1A2E2E"/>
-                </a:solidFill>
-                <a:latin typeface="Calibri" pitchFamily="34" charset="0"/>
-                <a:ea typeface="Calibri" pitchFamily="34" charset="-122"/>
-                <a:cs typeface="Calibri" pitchFamily="34" charset="-120"/>
-              </a:rPr>
-              <a:t>Enable BigLake, create the GCS bucket, register a REST catalog with credential vending on.</a:t>
+              <a:rPr lang="en-US" sz="1150" i="1" dirty="0">
+                <a:solidFill>
+                  <a:srgbClr val="5B6B6B"/>
+                </a:solidFill>
+                <a:latin typeface="Calibri" pitchFamily="34" charset="0"/>
+                <a:ea typeface="Calibri" pitchFamily="34" charset="-122"/>
+                <a:cs typeface="Calibri" pitchFamily="34" charset="-120"/>
+              </a:rPr>
+              <a:t>The GCS bucket now backing the catalog.</a:t>
             </a:r>
             <a:endParaRPr lang="en-US" sz="1150" dirty="0"/>
-          </a:p>
-        </p:txBody>
-      </p:sp>
-      <p:sp>
-        <p:nvSpPr>
-          <p:cNvPr id="8" name="Shape 6"/>
-          <p:cNvSpPr/>
-          <p:nvPr/>
-        </p:nvSpPr>
-        <p:spPr>
-          <a:xfrm>
-            <a:off x="594360" y="2057400"/>
-            <a:ext cx="384048" cy="384048"/>
-          </a:xfrm>
-          <a:prstGeom prst="ellipse">
-            <a:avLst/>
-          </a:prstGeom>
-          <a:solidFill>
-            <a:srgbClr val="0F5C56"/>
-          </a:solidFill>
-          <a:ln w="12700">
-            <a:solidFill>
-              <a:srgbClr val="0F5C56"/>
-            </a:solidFill>
-            <a:prstDash val="solid"/>
-          </a:ln>
-        </p:spPr>
-      </p:sp>
-      <p:sp>
-        <p:nvSpPr>
-          <p:cNvPr id="9" name="Text 7"/>
-          <p:cNvSpPr/>
-          <p:nvPr/>
-        </p:nvSpPr>
-        <p:spPr>
-          <a:xfrm>
-            <a:off x="594360" y="2057400"/>
-            <a:ext cx="384048" cy="384048"/>
-          </a:xfrm>
-          <a:prstGeom prst="rect">
-            <a:avLst/>
-          </a:prstGeom>
-          <a:noFill/>
-          <a:ln/>
-        </p:spPr>
-        <p:txBody>
-          <a:bodyPr wrap="square" lIns="0" tIns="0" rIns="0" bIns="0" rtlCol="0" anchor="ctr"/>
-          <a:lstStyle/>
-          <a:p>
-            <a:pPr algn="ctr" indent="0" marL="0">
-              <a:buNone/>
-            </a:pPr>
-            <a:r>
-              <a:rPr lang="en-US" sz="1300" b="1" dirty="0">
-                <a:solidFill>
-                  <a:srgbClr val="FFFFFF"/>
-                </a:solidFill>
-                <a:latin typeface="Cambria" pitchFamily="34" charset="0"/>
-                <a:ea typeface="Cambria" pitchFamily="34" charset="-122"/>
-                <a:cs typeface="Cambria" pitchFamily="34" charset="-120"/>
-              </a:rPr>
-              <a:t>2</a:t>
-            </a:r>
-            <a:endParaRPr lang="en-US" sz="1300" dirty="0"/>
-          </a:p>
-        </p:txBody>
-      </p:sp>
-      <p:sp>
-        <p:nvSpPr>
-          <p:cNvPr id="10" name="Text 8"/>
-          <p:cNvSpPr/>
-          <p:nvPr/>
-        </p:nvSpPr>
-        <p:spPr>
-          <a:xfrm>
-            <a:off x="1143000" y="2011680"/>
-            <a:ext cx="6126480" cy="713232"/>
-          </a:xfrm>
-          <a:prstGeom prst="rect">
-            <a:avLst/>
-          </a:prstGeom>
-          <a:noFill/>
-          <a:ln/>
-        </p:spPr>
-        <p:txBody>
-          <a:bodyPr wrap="square" lIns="0" tIns="0" rIns="0" bIns="0" rtlCol="0" anchor="t"/>
-          <a:lstStyle/>
-          <a:p>
-            <a:pPr indent="0" marL="0">
-              <a:buNone/>
-            </a:pPr>
-            <a:r>
-              <a:rPr lang="en-US" sz="1150" b="1" dirty="0">
-                <a:solidFill>
-                  <a:srgbClr val="0B3D3D"/>
-                </a:solidFill>
-                <a:latin typeface="Calibri" pitchFamily="34" charset="0"/>
-                <a:ea typeface="Calibri" pitchFamily="34" charset="-122"/>
-                <a:cs typeface="Calibri" pitchFamily="34" charset="-120"/>
-              </a:rPr>
-              <a:t>Write the table   </a:t>
-            </a:r>
-            <a:pPr indent="0" marL="0">
-              <a:buNone/>
-            </a:pPr>
-            <a:r>
-              <a:rPr lang="en-US" sz="1150" dirty="0">
-                <a:solidFill>
-                  <a:srgbClr val="1A2E2E"/>
-                </a:solidFill>
-                <a:latin typeface="Calibri" pitchFamily="34" charset="0"/>
-                <a:ea typeface="Calibri" pitchFamily="34" charset="-122"/>
-                <a:cs typeface="Calibri" pitchFamily="34" charset="-120"/>
-              </a:rPr>
-              <a:t>Spark (Dataproc Serverless) creates the namespace + Iceberg table and does the initial load.</a:t>
-            </a:r>
-            <a:endParaRPr lang="en-US" sz="1150" dirty="0"/>
-          </a:p>
-        </p:txBody>
-      </p:sp>
-      <p:sp>
-        <p:nvSpPr>
-          <p:cNvPr id="11" name="Shape 9"/>
-          <p:cNvSpPr/>
-          <p:nvPr/>
-        </p:nvSpPr>
-        <p:spPr>
-          <a:xfrm>
-            <a:off x="594360" y="2807208"/>
-            <a:ext cx="384048" cy="384048"/>
-          </a:xfrm>
-          <a:prstGeom prst="ellipse">
-            <a:avLst/>
-          </a:prstGeom>
-          <a:solidFill>
-            <a:srgbClr val="0F5C56"/>
-          </a:solidFill>
-          <a:ln w="12700">
-            <a:solidFill>
-              <a:srgbClr val="0F5C56"/>
-            </a:solidFill>
-            <a:prstDash val="solid"/>
-          </a:ln>
-        </p:spPr>
-      </p:sp>
-      <p:sp>
-        <p:nvSpPr>
-          <p:cNvPr id="12" name="Text 10"/>
-          <p:cNvSpPr/>
-          <p:nvPr/>
-        </p:nvSpPr>
-        <p:spPr>
-          <a:xfrm>
-            <a:off x="594360" y="2807208"/>
-            <a:ext cx="384048" cy="384048"/>
-          </a:xfrm>
-          <a:prstGeom prst="rect">
-            <a:avLst/>
-          </a:prstGeom>
-          <a:noFill/>
-          <a:ln/>
-        </p:spPr>
-        <p:txBody>
-          <a:bodyPr wrap="square" lIns="0" tIns="0" rIns="0" bIns="0" rtlCol="0" anchor="ctr"/>
-          <a:lstStyle/>
-          <a:p>
-            <a:pPr algn="ctr" indent="0" marL="0">
-              <a:buNone/>
-            </a:pPr>
-            <a:r>
-              <a:rPr lang="en-US" sz="1300" b="1" dirty="0">
-                <a:solidFill>
-                  <a:srgbClr val="FFFFFF"/>
-                </a:solidFill>
-                <a:latin typeface="Cambria" pitchFamily="34" charset="0"/>
-                <a:ea typeface="Cambria" pitchFamily="34" charset="-122"/>
-                <a:cs typeface="Cambria" pitchFamily="34" charset="-120"/>
-              </a:rPr>
-              <a:t>3</a:t>
-            </a:r>
-            <a:endParaRPr lang="en-US" sz="1300" dirty="0"/>
-          </a:p>
-        </p:txBody>
-      </p:sp>
-      <p:sp>
-        <p:nvSpPr>
-          <p:cNvPr id="13" name="Text 11"/>
-          <p:cNvSpPr/>
-          <p:nvPr/>
-        </p:nvSpPr>
-        <p:spPr>
-          <a:xfrm>
-            <a:off x="1143000" y="2761488"/>
-            <a:ext cx="6126480" cy="713232"/>
-          </a:xfrm>
-          <a:prstGeom prst="rect">
-            <a:avLst/>
-          </a:prstGeom>
-          <a:noFill/>
-          <a:ln/>
-        </p:spPr>
-        <p:txBody>
-          <a:bodyPr wrap="square" lIns="0" tIns="0" rIns="0" bIns="0" rtlCol="0" anchor="t"/>
-          <a:lstStyle/>
-          <a:p>
-            <a:pPr indent="0" marL="0">
-              <a:buNone/>
-            </a:pPr>
-            <a:r>
-              <a:rPr lang="en-US" sz="1150" b="1" dirty="0">
-                <a:solidFill>
-                  <a:srgbClr val="0B3D3D"/>
-                </a:solidFill>
-                <a:latin typeface="Calibri" pitchFamily="34" charset="0"/>
-                <a:ea typeface="Calibri" pitchFamily="34" charset="-122"/>
-                <a:cs typeface="Calibri" pitchFamily="34" charset="-120"/>
-              </a:rPr>
-              <a:t>Keyless trust   </a:t>
-            </a:r>
-            <a:pPr indent="0" marL="0">
-              <a:buNone/>
-            </a:pPr>
-            <a:r>
-              <a:rPr lang="en-US" sz="1150" dirty="0">
-                <a:solidFill>
-                  <a:srgbClr val="1A2E2E"/>
-                </a:solidFill>
-                <a:latin typeface="Calibri" pitchFamily="34" charset="0"/>
-                <a:ea typeface="Calibri" pitchFamily="34" charset="-122"/>
-                <a:cs typeface="Calibri" pitchFamily="34" charset="-120"/>
-              </a:rPr>
-              <a:t>Snowflake issuer URL -&gt; GCP workload-identity pool + provider; grant the principal read-only.</a:t>
-            </a:r>
-            <a:endParaRPr lang="en-US" sz="1150" dirty="0"/>
-          </a:p>
-        </p:txBody>
-      </p:sp>
-      <p:sp>
-        <p:nvSpPr>
-          <p:cNvPr id="14" name="Shape 12"/>
-          <p:cNvSpPr/>
-          <p:nvPr/>
-        </p:nvSpPr>
-        <p:spPr>
-          <a:xfrm>
-            <a:off x="594360" y="3557016"/>
-            <a:ext cx="384048" cy="384048"/>
-          </a:xfrm>
-          <a:prstGeom prst="ellipse">
-            <a:avLst/>
-          </a:prstGeom>
-          <a:solidFill>
-            <a:srgbClr val="0F5C56"/>
-          </a:solidFill>
-          <a:ln w="12700">
-            <a:solidFill>
-              <a:srgbClr val="0F5C56"/>
-            </a:solidFill>
-            <a:prstDash val="solid"/>
-          </a:ln>
-        </p:spPr>
-      </p:sp>
-      <p:sp>
-        <p:nvSpPr>
-          <p:cNvPr id="15" name="Text 13"/>
-          <p:cNvSpPr/>
-          <p:nvPr/>
-        </p:nvSpPr>
-        <p:spPr>
-          <a:xfrm>
-            <a:off x="594360" y="3557016"/>
-            <a:ext cx="384048" cy="384048"/>
-          </a:xfrm>
-          <a:prstGeom prst="rect">
-            <a:avLst/>
-          </a:prstGeom>
-          <a:noFill/>
-          <a:ln/>
-        </p:spPr>
-        <p:txBody>
-          <a:bodyPr wrap="square" lIns="0" tIns="0" rIns="0" bIns="0" rtlCol="0" anchor="ctr"/>
-          <a:lstStyle/>
-          <a:p>
-            <a:pPr algn="ctr" indent="0" marL="0">
-              <a:buNone/>
-            </a:pPr>
-            <a:r>
-              <a:rPr lang="en-US" sz="1300" b="1" dirty="0">
-                <a:solidFill>
-                  <a:srgbClr val="FFFFFF"/>
-                </a:solidFill>
-                <a:latin typeface="Cambria" pitchFamily="34" charset="0"/>
-                <a:ea typeface="Cambria" pitchFamily="34" charset="-122"/>
-                <a:cs typeface="Cambria" pitchFamily="34" charset="-120"/>
-              </a:rPr>
-              <a:t>4</a:t>
-            </a:r>
-            <a:endParaRPr lang="en-US" sz="1300" dirty="0"/>
-          </a:p>
-        </p:txBody>
-      </p:sp>
-      <p:sp>
-        <p:nvSpPr>
-          <p:cNvPr id="16" name="Text 14"/>
-          <p:cNvSpPr/>
-          <p:nvPr/>
-        </p:nvSpPr>
-        <p:spPr>
-          <a:xfrm>
-            <a:off x="1143000" y="3511296"/>
-            <a:ext cx="6126480" cy="713232"/>
-          </a:xfrm>
-          <a:prstGeom prst="rect">
-            <a:avLst/>
-          </a:prstGeom>
-          <a:noFill/>
-          <a:ln/>
-        </p:spPr>
-        <p:txBody>
-          <a:bodyPr wrap="square" lIns="0" tIns="0" rIns="0" bIns="0" rtlCol="0" anchor="t"/>
-          <a:lstStyle/>
-          <a:p>
-            <a:pPr indent="0" marL="0">
-              <a:buNone/>
-            </a:pPr>
-            <a:r>
-              <a:rPr lang="en-US" sz="1150" b="1" dirty="0">
-                <a:solidFill>
-                  <a:srgbClr val="0B3D3D"/>
-                </a:solidFill>
-                <a:latin typeface="Calibri" pitchFamily="34" charset="0"/>
-                <a:ea typeface="Calibri" pitchFamily="34" charset="-122"/>
-                <a:cs typeface="Calibri" pitchFamily="34" charset="-120"/>
-              </a:rPr>
-              <a:t>Catalog integration   </a:t>
-            </a:r>
-            <a:pPr indent="0" marL="0">
-              <a:buNone/>
-            </a:pPr>
-            <a:r>
-              <a:rPr lang="en-US" sz="1150" dirty="0">
-                <a:solidFill>
-                  <a:srgbClr val="1A2E2E"/>
-                </a:solidFill>
-                <a:latin typeface="Calibri" pitchFamily="34" charset="0"/>
-                <a:ea typeface="Calibri" pitchFamily="34" charset="-122"/>
-                <a:cs typeface="Calibri" pitchFamily="34" charset="-120"/>
-              </a:rPr>
-              <a:t>Snowflake CATALOG INTEGRATION with TOKEN_EXCHANGE + vended credentials; verify it.</a:t>
-            </a:r>
-            <a:endParaRPr lang="en-US" sz="1150" dirty="0"/>
-          </a:p>
-        </p:txBody>
-      </p:sp>
-      <p:sp>
-        <p:nvSpPr>
-          <p:cNvPr id="17" name="Shape 15"/>
-          <p:cNvSpPr/>
-          <p:nvPr/>
-        </p:nvSpPr>
-        <p:spPr>
-          <a:xfrm>
-            <a:off x="594360" y="4306824"/>
-            <a:ext cx="384048" cy="384048"/>
-          </a:xfrm>
-          <a:prstGeom prst="ellipse">
-            <a:avLst/>
-          </a:prstGeom>
-          <a:solidFill>
-            <a:srgbClr val="0F5C56"/>
-          </a:solidFill>
-          <a:ln w="12700">
-            <a:solidFill>
-              <a:srgbClr val="0F5C56"/>
-            </a:solidFill>
-            <a:prstDash val="solid"/>
-          </a:ln>
-        </p:spPr>
-      </p:sp>
-      <p:sp>
-        <p:nvSpPr>
-          <p:cNvPr id="18" name="Text 16"/>
-          <p:cNvSpPr/>
-          <p:nvPr/>
-        </p:nvSpPr>
-        <p:spPr>
-          <a:xfrm>
-            <a:off x="594360" y="4306824"/>
-            <a:ext cx="384048" cy="384048"/>
-          </a:xfrm>
-          <a:prstGeom prst="rect">
-            <a:avLst/>
-          </a:prstGeom>
-          <a:noFill/>
-          <a:ln/>
-        </p:spPr>
-        <p:txBody>
-          <a:bodyPr wrap="square" lIns="0" tIns="0" rIns="0" bIns="0" rtlCol="0" anchor="ctr"/>
-          <a:lstStyle/>
-          <a:p>
-            <a:pPr algn="ctr" indent="0" marL="0">
-              <a:buNone/>
-            </a:pPr>
-            <a:r>
-              <a:rPr lang="en-US" sz="1300" b="1" dirty="0">
-                <a:solidFill>
-                  <a:srgbClr val="FFFFFF"/>
-                </a:solidFill>
-                <a:latin typeface="Cambria" pitchFamily="34" charset="0"/>
-                <a:ea typeface="Cambria" pitchFamily="34" charset="-122"/>
-                <a:cs typeface="Cambria" pitchFamily="34" charset="-120"/>
-              </a:rPr>
-              <a:t>5</a:t>
-            </a:r>
-            <a:endParaRPr lang="en-US" sz="1300" dirty="0"/>
-          </a:p>
-        </p:txBody>
-      </p:sp>
-      <p:sp>
-        <p:nvSpPr>
-          <p:cNvPr id="19" name="Text 17"/>
-          <p:cNvSpPr/>
-          <p:nvPr/>
-        </p:nvSpPr>
-        <p:spPr>
-          <a:xfrm>
-            <a:off x="1143000" y="4261104"/>
-            <a:ext cx="6126480" cy="713232"/>
-          </a:xfrm>
-          <a:prstGeom prst="rect">
-            <a:avLst/>
-          </a:prstGeom>
-          <a:noFill/>
-          <a:ln/>
-        </p:spPr>
-        <p:txBody>
-          <a:bodyPr wrap="square" lIns="0" tIns="0" rIns="0" bIns="0" rtlCol="0" anchor="t"/>
-          <a:lstStyle/>
-          <a:p>
-            <a:pPr indent="0" marL="0">
-              <a:buNone/>
-            </a:pPr>
-            <a:r>
-              <a:rPr lang="en-US" sz="1150" b="1" dirty="0">
-                <a:solidFill>
-                  <a:srgbClr val="0B3D3D"/>
-                </a:solidFill>
-                <a:latin typeface="Calibri" pitchFamily="34" charset="0"/>
-                <a:ea typeface="Calibri" pitchFamily="34" charset="-122"/>
-                <a:cs typeface="Calibri" pitchFamily="34" charset="-120"/>
-              </a:rPr>
-              <a:t>Catalog-linked DB + read   </a:t>
-            </a:r>
-            <a:pPr indent="0" marL="0">
-              <a:buNone/>
-            </a:pPr>
-            <a:r>
-              <a:rPr lang="en-US" sz="1150" dirty="0">
-                <a:solidFill>
-                  <a:srgbClr val="1A2E2E"/>
-                </a:solidFill>
-                <a:latin typeface="Calibri" pitchFamily="34" charset="0"/>
-                <a:ea typeface="Calibri" pitchFamily="34" charset="-122"/>
-                <a:cs typeface="Calibri" pitchFamily="34" charset="-120"/>
-              </a:rPr>
-              <a:t>CREATE DATABASE ... LINKED_CATALOG, wait for discovery, then a plain SELECT.</a:t>
-            </a:r>
-            <a:endParaRPr lang="en-US" sz="1150" dirty="0"/>
-          </a:p>
-        </p:txBody>
-      </p:sp>
-      <p:sp>
-        <p:nvSpPr>
-          <p:cNvPr id="20" name="Shape 18"/>
-          <p:cNvSpPr/>
-          <p:nvPr/>
-        </p:nvSpPr>
-        <p:spPr>
-          <a:xfrm>
-            <a:off x="7452360" y="1280160"/>
-            <a:ext cx="4206240" cy="3749040"/>
-          </a:xfrm>
-          <a:prstGeom prst="roundRect">
-            <a:avLst>
-              <a:gd name="adj" fmla="val 1463"/>
-            </a:avLst>
-          </a:prstGeom>
-          <a:solidFill>
-            <a:srgbClr val="F4F4F3"/>
-          </a:solidFill>
-          <a:ln w="17780">
-            <a:solidFill>
-              <a:srgbClr val="D8D8D6"/>
-            </a:solidFill>
-            <a:prstDash val="solid"/>
-          </a:ln>
-        </p:spPr>
-      </p:sp>
-      <p:sp>
-        <p:nvSpPr>
-          <p:cNvPr id="21" name="Text 19"/>
-          <p:cNvSpPr/>
-          <p:nvPr/>
-        </p:nvSpPr>
-        <p:spPr>
-          <a:xfrm>
-            <a:off x="7680960" y="1417320"/>
-            <a:ext cx="3749040" cy="274320"/>
-          </a:xfrm>
-          <a:prstGeom prst="rect">
-            <a:avLst/>
-          </a:prstGeom>
-          <a:noFill/>
-          <a:ln/>
-        </p:spPr>
-        <p:txBody>
-          <a:bodyPr wrap="square" lIns="0" tIns="0" rIns="0" bIns="0" rtlCol="0" anchor="ctr"/>
-          <a:lstStyle/>
-          <a:p>
-            <a:pPr indent="0" marL="0">
-              <a:buNone/>
-            </a:pPr>
-            <a:r>
-              <a:rPr lang="en-US" sz="1250" b="1" dirty="0">
-                <a:solidFill>
-                  <a:srgbClr val="C1502E"/>
-                </a:solidFill>
-                <a:latin typeface="Calibri" pitchFamily="34" charset="0"/>
-                <a:ea typeface="Calibri" pitchFamily="34" charset="-122"/>
-                <a:cs typeface="Calibri" pitchFamily="34" charset="-120"/>
-              </a:rPr>
-              <a:t>Sharp edges</a:t>
-            </a:r>
-            <a:endParaRPr lang="en-US" sz="1250" dirty="0"/>
-          </a:p>
-        </p:txBody>
-      </p:sp>
-      <p:sp>
-        <p:nvSpPr>
-          <p:cNvPr id="22" name="Text 20"/>
-          <p:cNvSpPr/>
-          <p:nvPr/>
-        </p:nvSpPr>
-        <p:spPr>
-          <a:xfrm>
-            <a:off x="7680960" y="1737360"/>
-            <a:ext cx="3749040" cy="3108960"/>
-          </a:xfrm>
-          <a:prstGeom prst="rect">
-            <a:avLst/>
-          </a:prstGeom>
-          <a:noFill/>
-          <a:ln/>
-        </p:spPr>
-        <p:txBody>
-          <a:bodyPr wrap="square" lIns="0" tIns="0" rIns="0" bIns="0" rtlCol="0" anchor="t"/>
-          <a:lstStyle/>
-          <a:p>
-            <a:pPr marL="342900" indent="-342900">
-              <a:spcAft>
-                <a:spcPts val="800"/>
-              </a:spcAft>
-              <a:buSzPct val="100000"/>
-              <a:buChar char="•"/>
-            </a:pPr>
-            <a:r>
-              <a:rPr lang="en-US" sz="1050" dirty="0">
-                <a:solidFill>
-                  <a:srgbClr val="1A2E2E"/>
-                </a:solidFill>
-                <a:latin typeface="Calibri" pitchFamily="34" charset="0"/>
-                <a:ea typeface="Calibri" pitchFamily="34" charset="-122"/>
-                <a:cs typeface="Calibri" pitchFamily="34" charset="-120"/>
-              </a:rPr>
-              <a:t>The catalog runtime identity needs an explicit storage grant — not automatic</a:t>
-            </a:r>
-            <a:endParaRPr lang="en-US" sz="1050" dirty="0"/>
-          </a:p>
-          <a:p>
-            <a:pPr marL="342900" indent="-342900">
-              <a:spcAft>
-                <a:spcPts val="800"/>
-              </a:spcAft>
-              <a:buSzPct val="100000"/>
-              <a:buChar char="•"/>
-            </a:pPr>
-            <a:r>
-              <a:rPr lang="en-US" sz="1050" dirty="0">
-                <a:solidFill>
-                  <a:srgbClr val="1A2E2E"/>
-                </a:solidFill>
-                <a:latin typeface="Calibri" pitchFamily="34" charset="0"/>
-                <a:ea typeface="Calibri" pitchFamily="34" charset="-122"/>
-                <a:cs typeface="Calibri" pitchFamily="34" charset="-120"/>
-              </a:rPr>
-              <a:t>The Snowflake principal also needs rights to use the project's billed APIs</a:t>
-            </a:r>
-            <a:endParaRPr lang="en-US" sz="1050" dirty="0"/>
-          </a:p>
-          <a:p>
-            <a:pPr marL="342900" indent="-342900">
-              <a:spcAft>
-                <a:spcPts val="800"/>
-              </a:spcAft>
-              <a:buSzPct val="100000"/>
-              <a:buChar char="•"/>
-            </a:pPr>
-            <a:r>
-              <a:rPr lang="en-US" sz="1050" dirty="0">
-                <a:solidFill>
-                  <a:srgbClr val="1A2E2E"/>
-                </a:solidFill>
-                <a:latin typeface="Calibri" pitchFamily="34" charset="0"/>
-                <a:ea typeface="Calibri" pitchFamily="34" charset="-122"/>
-                <a:cs typeface="Calibri" pitchFamily="34" charset="-120"/>
-              </a:rPr>
-              <a:t>CREATE OR REPLACE integration mints a NEW trust subject — re-grant</a:t>
-            </a:r>
-            <a:endParaRPr lang="en-US" sz="1050" dirty="0"/>
-          </a:p>
-          <a:p>
-            <a:pPr marL="342900" indent="-342900">
-              <a:spcAft>
-                <a:spcPts val="800"/>
-              </a:spcAft>
-              <a:buSzPct val="100000"/>
-              <a:buChar char="•"/>
-            </a:pPr>
-            <a:r>
-              <a:rPr lang="en-US" sz="1050" dirty="0">
-                <a:solidFill>
-                  <a:srgbClr val="1A2E2E"/>
-                </a:solidFill>
-                <a:latin typeface="Calibri" pitchFamily="34" charset="0"/>
-                <a:ea typeface="Calibri" pitchFamily="34" charset="-122"/>
-                <a:cs typeface="Calibri" pitchFamily="34" charset="-120"/>
-              </a:rPr>
-              <a:t>Vended credentials must be enabled or the linked DB refuses to create</a:t>
-            </a:r>
-            <a:endParaRPr lang="en-US" sz="1050" dirty="0"/>
-          </a:p>
-          <a:p>
-            <a:pPr marL="342900" indent="-342900">
-              <a:spcAft>
-                <a:spcPts val="800"/>
-              </a:spcAft>
-              <a:buSzPct val="100000"/>
-              <a:buChar char="•"/>
-            </a:pPr>
-            <a:r>
-              <a:rPr lang="en-US" sz="1050" dirty="0">
-                <a:solidFill>
-                  <a:srgbClr val="1A2E2E"/>
-                </a:solidFill>
-                <a:latin typeface="Calibri" pitchFamily="34" charset="0"/>
-                <a:ea typeface="Calibri" pitchFamily="34" charset="-122"/>
-                <a:cs typeface="Calibri" pitchFamily="34" charset="-120"/>
-              </a:rPr>
-              <a:t>Discovery is async; give it a minute before the schema appears</a:t>
-            </a:r>
-            <a:endParaRPr lang="en-US" sz="1050" dirty="0"/>
-          </a:p>
-        </p:txBody>
-      </p:sp>
-      <p:sp>
-        <p:nvSpPr>
-          <p:cNvPr id="23" name="Text 21"/>
-          <p:cNvSpPr/>
-          <p:nvPr/>
-        </p:nvSpPr>
-        <p:spPr>
-          <a:xfrm>
-            <a:off x="548640" y="5212080"/>
-            <a:ext cx="10972800" cy="365760"/>
-          </a:xfrm>
-          <a:prstGeom prst="rect">
-            <a:avLst/>
-          </a:prstGeom>
-          <a:noFill/>
-          <a:ln/>
-        </p:spPr>
-        <p:txBody>
-          <a:bodyPr wrap="square" lIns="0" tIns="0" rIns="0" bIns="0" rtlCol="0" anchor="ctr"/>
-          <a:lstStyle/>
-          <a:p>
-            <a:pPr indent="0" marL="0">
-              <a:buNone/>
-            </a:pPr>
-            <a:r>
-              <a:rPr lang="en-US" sz="1050" i="1" dirty="0">
-                <a:solidFill>
-                  <a:srgbClr val="5B6B6B"/>
-                </a:solidFill>
-                <a:latin typeface="Calibri" pitchFamily="34" charset="0"/>
-                <a:ea typeface="Calibri" pitchFamily="34" charset="-122"/>
-                <a:cs typeface="Calibri" pitchFamily="34" charset="-120"/>
-              </a:rPr>
-              <a:t>Full detail lives in the project runbook and as-run log.</a:t>
-            </a:r>
-            <a:endParaRPr lang="en-US" sz="1050" dirty="0"/>
           </a:p>
         </p:txBody>
       </p:sp>
@@ -5649,7 +5369,7 @@
                 <a:ea typeface="Cambria" pitchFamily="34" charset="-122"/>
                 <a:cs typeface="Cambria" pitchFamily="34" charset="-120"/>
               </a:rPr>
-              <a:t>Appendix B — Proof: The Lake in GCS</a:t>
+              <a:t>Appendix  ·  Step 2 of 5 — Write the Table</a:t>
             </a:r>
             <a:endParaRPr lang="en-US" sz="2800" dirty="0"/>
           </a:p>
@@ -5688,7 +5408,7 @@
                 <a:ea typeface="Calibri" pitchFamily="34" charset="-122"/>
                 <a:cs typeface="Calibri" pitchFamily="34" charset="-120"/>
               </a:rPr>
-              <a:t>A bucket, and inside it an ordinary Iceberg table: metadata/ + data/</a:t>
+              <a:t>BigQuery cannot DDL here — Spark (Dataproc Serverless) creates and loads the table</a:t>
             </a:r>
             <a:endParaRPr lang="en-US" sz="1400" dirty="0"/>
           </a:p>
@@ -5735,46 +5455,323 @@
       </p:sp>
       <p:sp>
         <p:nvSpPr>
-          <p:cNvPr id="5" name="Text 3"/>
-          <p:cNvSpPr/>
-          <p:nvPr/>
-        </p:nvSpPr>
-        <p:spPr>
-          <a:xfrm>
-            <a:off x="548640" y="1234440"/>
-            <a:ext cx="10972800" cy="320040"/>
-          </a:xfrm>
-          <a:prstGeom prst="rect">
-            <a:avLst/>
-          </a:prstGeom>
-          <a:noFill/>
-          <a:ln/>
-        </p:spPr>
-        <p:txBody>
-          <a:bodyPr wrap="square" lIns="0" tIns="0" rIns="0" bIns="0" rtlCol="0" anchor="ctr"/>
-          <a:lstStyle/>
-          <a:p>
-            <a:pPr indent="0" marL="0">
-              <a:buNone/>
-            </a:pPr>
-            <a:r>
-              <a:rPr lang="en-US" sz="1300" b="1" dirty="0">
-                <a:solidFill>
-                  <a:srgbClr val="0B3D3D"/>
-                </a:solidFill>
-                <a:latin typeface="Calibri" pitchFamily="34" charset="0"/>
-                <a:ea typeface="Calibri" pitchFamily="34" charset="-122"/>
-                <a:cs typeface="Calibri" pitchFamily="34" charset="-120"/>
-              </a:rPr>
-              <a:t>1.  The GCS bucket backing the catalog</a:t>
-            </a:r>
-            <a:endParaRPr lang="en-US" sz="1300" dirty="0"/>
+          <p:cNvPr id="5" name="Shape 3"/>
+          <p:cNvSpPr/>
+          <p:nvPr/>
+        </p:nvSpPr>
+        <p:spPr>
+          <a:xfrm>
+            <a:off x="548640" y="1371600"/>
+            <a:ext cx="5623560" cy="4297680"/>
+          </a:xfrm>
+          <a:prstGeom prst="roundRect">
+            <a:avLst>
+              <a:gd name="adj" fmla="val 1064"/>
+            </a:avLst>
+          </a:prstGeom>
+          <a:solidFill>
+            <a:srgbClr val="0E2A2A"/>
+          </a:solidFill>
+          <a:ln w="12700">
+            <a:solidFill>
+              <a:srgbClr val="0E2A2A"/>
+            </a:solidFill>
+            <a:prstDash val="solid"/>
+          </a:ln>
+        </p:spPr>
+      </p:sp>
+      <p:sp>
+        <p:nvSpPr>
+          <p:cNvPr id="6" name="Text 4"/>
+          <p:cNvSpPr/>
+          <p:nvPr/>
+        </p:nvSpPr>
+        <p:spPr>
+          <a:xfrm>
+            <a:off x="713232" y="1499616"/>
+            <a:ext cx="5294376" cy="4041648"/>
+          </a:xfrm>
+          <a:prstGeom prst="rect">
+            <a:avLst/>
+          </a:prstGeom>
+          <a:noFill/>
+          <a:ln/>
+        </p:spPr>
+        <p:txBody>
+          <a:bodyPr wrap="square" lIns="0" tIns="0" rIns="0" bIns="0" rtlCol="0" anchor="t"/>
+          <a:lstStyle/>
+          <a:p>
+            <a:pPr algn="l" indent="0" marL="0">
+              <a:lnSpc>
+                <a:spcPct val="105000"/>
+              </a:lnSpc>
+              <a:buNone/>
+            </a:pPr>
+            <a:r>
+              <a:rPr lang="en-US" sz="950" dirty="0">
+                <a:solidFill>
+                  <a:srgbClr val="CFE8E6"/>
+                </a:solidFill>
+                <a:latin typeface="Courier New" pitchFamily="34" charset="0"/>
+                <a:ea typeface="Courier New" pitchFamily="34" charset="-122"/>
+                <a:cs typeface="Courier New" pitchFamily="34" charset="-120"/>
+              </a:rPr>
+              <a:t># Spark writes the Iceberg table</a:t>
+            </a:r>
+            <a:endParaRPr lang="en-US" sz="950" dirty="0"/>
+          </a:p>
+          <a:p>
+            <a:pPr algn="l" indent="0" marL="0">
+              <a:lnSpc>
+                <a:spcPct val="105000"/>
+              </a:lnSpc>
+              <a:buNone/>
+            </a:pPr>
+            <a:r>
+              <a:rPr lang="en-US" sz="950" dirty="0">
+                <a:solidFill>
+                  <a:srgbClr val="CFE8E6"/>
+                </a:solidFill>
+                <a:latin typeface="Courier New" pitchFamily="34" charset="0"/>
+                <a:ea typeface="Courier New" pitchFamily="34" charset="-122"/>
+                <a:cs typeface="Courier New" pitchFamily="34" charset="-120"/>
+              </a:rPr>
+              <a:t># via the same REST catalog.</a:t>
+            </a:r>
+            <a:endParaRPr lang="en-US" sz="950" dirty="0"/>
+          </a:p>
+          <a:p>
+            <a:pPr algn="l" indent="0" marL="0">
+              <a:lnSpc>
+                <a:spcPct val="105000"/>
+              </a:lnSpc>
+              <a:buNone/>
+            </a:pPr>
+            <a:endParaRPr lang="en-US" sz="950" dirty="0"/>
+          </a:p>
+          <a:p>
+            <a:pPr algn="l" indent="0" marL="0">
+              <a:lnSpc>
+                <a:spcPct val="105000"/>
+              </a:lnSpc>
+              <a:buNone/>
+            </a:pPr>
+            <a:r>
+              <a:rPr lang="en-US" sz="950" dirty="0">
+                <a:solidFill>
+                  <a:srgbClr val="CFE8E6"/>
+                </a:solidFill>
+                <a:latin typeface="Courier New" pitchFamily="34" charset="0"/>
+                <a:ea typeface="Courier New" pitchFamily="34" charset="-122"/>
+                <a:cs typeface="Courier New" pitchFamily="34" charset="-120"/>
+              </a:rPr>
+              <a:t>spark.sql("CREATE NAMESPACE IF NOT "</a:t>
+            </a:r>
+            <a:endParaRPr lang="en-US" sz="950" dirty="0"/>
+          </a:p>
+          <a:p>
+            <a:pPr algn="l" indent="0" marL="0">
+              <a:lnSpc>
+                <a:spcPct val="105000"/>
+              </a:lnSpc>
+              <a:buNone/>
+            </a:pPr>
+            <a:r>
+              <a:rPr lang="en-US" sz="950" dirty="0">
+                <a:solidFill>
+                  <a:srgbClr val="CFE8E6"/>
+                </a:solidFill>
+                <a:latin typeface="Courier New" pitchFamily="34" charset="0"/>
+                <a:ea typeface="Courier New" pitchFamily="34" charset="-122"/>
+                <a:cs typeface="Courier New" pitchFamily="34" charset="-120"/>
+              </a:rPr>
+              <a:t>  "EXISTS shared_aws")</a:t>
+            </a:r>
+            <a:endParaRPr lang="en-US" sz="950" dirty="0"/>
+          </a:p>
+          <a:p>
+            <a:pPr algn="l" indent="0" marL="0">
+              <a:lnSpc>
+                <a:spcPct val="105000"/>
+              </a:lnSpc>
+              <a:buNone/>
+            </a:pPr>
+            <a:endParaRPr lang="en-US" sz="950" dirty="0"/>
+          </a:p>
+          <a:p>
+            <a:pPr algn="l" indent="0" marL="0">
+              <a:lnSpc>
+                <a:spcPct val="105000"/>
+              </a:lnSpc>
+              <a:buNone/>
+            </a:pPr>
+            <a:r>
+              <a:rPr lang="en-US" sz="950" dirty="0">
+                <a:solidFill>
+                  <a:srgbClr val="CFE8E6"/>
+                </a:solidFill>
+                <a:latin typeface="Courier New" pitchFamily="34" charset="0"/>
+                <a:ea typeface="Courier New" pitchFamily="34" charset="-122"/>
+                <a:cs typeface="Courier New" pitchFamily="34" charset="-120"/>
+              </a:rPr>
+              <a:t>spark.sql("""</a:t>
+            </a:r>
+            <a:endParaRPr lang="en-US" sz="950" dirty="0"/>
+          </a:p>
+          <a:p>
+            <a:pPr algn="l" indent="0" marL="0">
+              <a:lnSpc>
+                <a:spcPct val="105000"/>
+              </a:lnSpc>
+              <a:buNone/>
+            </a:pPr>
+            <a:r>
+              <a:rPr lang="en-US" sz="950" dirty="0">
+                <a:solidFill>
+                  <a:srgbClr val="CFE8E6"/>
+                </a:solidFill>
+                <a:latin typeface="Courier New" pitchFamily="34" charset="0"/>
+                <a:ea typeface="Courier New" pitchFamily="34" charset="-122"/>
+                <a:cs typeface="Courier New" pitchFamily="34" charset="-120"/>
+              </a:rPr>
+              <a:t>  CREATE TABLE shared_aws.orders (</a:t>
+            </a:r>
+            <a:endParaRPr lang="en-US" sz="950" dirty="0"/>
+          </a:p>
+          <a:p>
+            <a:pPr algn="l" indent="0" marL="0">
+              <a:lnSpc>
+                <a:spcPct val="105000"/>
+              </a:lnSpc>
+              <a:buNone/>
+            </a:pPr>
+            <a:r>
+              <a:rPr lang="en-US" sz="950" dirty="0">
+                <a:solidFill>
+                  <a:srgbClr val="CFE8E6"/>
+                </a:solidFill>
+                <a:latin typeface="Courier New" pitchFamily="34" charset="0"/>
+                <a:ea typeface="Courier New" pitchFamily="34" charset="-122"/>
+                <a:cs typeface="Courier New" pitchFamily="34" charset="-120"/>
+              </a:rPr>
+              <a:t>    order_id  BIGINT,</a:t>
+            </a:r>
+            <a:endParaRPr lang="en-US" sz="950" dirty="0"/>
+          </a:p>
+          <a:p>
+            <a:pPr algn="l" indent="0" marL="0">
+              <a:lnSpc>
+                <a:spcPct val="105000"/>
+              </a:lnSpc>
+              <a:buNone/>
+            </a:pPr>
+            <a:r>
+              <a:rPr lang="en-US" sz="950" dirty="0">
+                <a:solidFill>
+                  <a:srgbClr val="CFE8E6"/>
+                </a:solidFill>
+                <a:latin typeface="Courier New" pitchFamily="34" charset="0"/>
+                <a:ea typeface="Courier New" pitchFamily="34" charset="-122"/>
+                <a:cs typeface="Courier New" pitchFamily="34" charset="-120"/>
+              </a:rPr>
+              <a:t>    customer  STRING,</a:t>
+            </a:r>
+            <a:endParaRPr lang="en-US" sz="950" dirty="0"/>
+          </a:p>
+          <a:p>
+            <a:pPr algn="l" indent="0" marL="0">
+              <a:lnSpc>
+                <a:spcPct val="105000"/>
+              </a:lnSpc>
+              <a:buNone/>
+            </a:pPr>
+            <a:r>
+              <a:rPr lang="en-US" sz="950" dirty="0">
+                <a:solidFill>
+                  <a:srgbClr val="CFE8E6"/>
+                </a:solidFill>
+                <a:latin typeface="Courier New" pitchFamily="34" charset="0"/>
+                <a:ea typeface="Courier New" pitchFamily="34" charset="-122"/>
+                <a:cs typeface="Courier New" pitchFamily="34" charset="-120"/>
+              </a:rPr>
+              <a:t>    amount    DECIMAL(10,2),</a:t>
+            </a:r>
+            <a:endParaRPr lang="en-US" sz="950" dirty="0"/>
+          </a:p>
+          <a:p>
+            <a:pPr algn="l" indent="0" marL="0">
+              <a:lnSpc>
+                <a:spcPct val="105000"/>
+              </a:lnSpc>
+              <a:buNone/>
+            </a:pPr>
+            <a:r>
+              <a:rPr lang="en-US" sz="950" dirty="0">
+                <a:solidFill>
+                  <a:srgbClr val="CFE8E6"/>
+                </a:solidFill>
+                <a:latin typeface="Courier New" pitchFamily="34" charset="0"/>
+                <a:ea typeface="Courier New" pitchFamily="34" charset="-122"/>
+                <a:cs typeface="Courier New" pitchFamily="34" charset="-120"/>
+              </a:rPr>
+              <a:t>    order_ts  TIMESTAMP )</a:t>
+            </a:r>
+            <a:endParaRPr lang="en-US" sz="950" dirty="0"/>
+          </a:p>
+          <a:p>
+            <a:pPr algn="l" indent="0" marL="0">
+              <a:lnSpc>
+                <a:spcPct val="105000"/>
+              </a:lnSpc>
+              <a:buNone/>
+            </a:pPr>
+            <a:r>
+              <a:rPr lang="en-US" sz="950" dirty="0">
+                <a:solidFill>
+                  <a:srgbClr val="CFE8E6"/>
+                </a:solidFill>
+                <a:latin typeface="Courier New" pitchFamily="34" charset="0"/>
+                <a:ea typeface="Courier New" pitchFamily="34" charset="-122"/>
+                <a:cs typeface="Courier New" pitchFamily="34" charset="-120"/>
+              </a:rPr>
+              <a:t>  USING iceberg""")</a:t>
+            </a:r>
+            <a:endParaRPr lang="en-US" sz="950" dirty="0"/>
+          </a:p>
+          <a:p>
+            <a:pPr algn="l" indent="0" marL="0">
+              <a:lnSpc>
+                <a:spcPct val="105000"/>
+              </a:lnSpc>
+              <a:buNone/>
+            </a:pPr>
+            <a:endParaRPr lang="en-US" sz="950" dirty="0"/>
+          </a:p>
+          <a:p>
+            <a:pPr algn="l" indent="0" marL="0">
+              <a:lnSpc>
+                <a:spcPct val="105000"/>
+              </a:lnSpc>
+              <a:buNone/>
+            </a:pPr>
+            <a:r>
+              <a:rPr lang="en-US" sz="950" dirty="0">
+                <a:solidFill>
+                  <a:srgbClr val="CFE8E6"/>
+                </a:solidFill>
+                <a:latin typeface="Courier New" pitchFamily="34" charset="0"/>
+                <a:ea typeface="Courier New" pitchFamily="34" charset="-122"/>
+                <a:cs typeface="Courier New" pitchFamily="34" charset="-120"/>
+              </a:rPr>
+              <a:t># INSERT rows, submit as a batch</a:t>
+            </a:r>
+            <a:endParaRPr lang="en-US" sz="950" dirty="0"/>
           </a:p>
         </p:txBody>
       </p:sp>
       <p:pic>
         <p:nvPicPr>
-          <p:cNvPr id="6" name="Image 0" descr="C:/Users/jerem/AppData/Local/Temp/claude/C--claude/ae2a9827-8b94-4dcd-a82b-a6eb63227025/scratchpad/redacted-gcs_bucket_for__iceberg.png">    </p:cNvPr>
+          <p:cNvPr id="7" name="Image 0" descr="C:/Users/jerem/AppData/Local/Temp/claude/C--claude/ae2a9827-8b94-4dcd-a82b-a6eb63227025/scratchpad/redacted-gcs_bucket_for__iceberg_zero_copy_path.png">    </p:cNvPr>
           <p:cNvPicPr>
             <a:picLocks noChangeAspect="1"/>
           </p:cNvPicPr>
@@ -5788,8 +5785,8 @@
         </p:blipFill>
         <p:spPr>
           <a:xfrm>
-            <a:off x="548640" y="1645920"/>
-            <a:ext cx="7315200" cy="244141"/>
+            <a:off x="6355080" y="2275251"/>
+            <a:ext cx="5394960" cy="1758858"/>
           </a:xfrm>
           <a:prstGeom prst="rect">
             <a:avLst/>
@@ -5798,129 +5795,40 @@
       </p:pic>
       <p:sp>
         <p:nvSpPr>
-          <p:cNvPr id="7" name="Text 4"/>
-          <p:cNvSpPr/>
-          <p:nvPr/>
-        </p:nvSpPr>
-        <p:spPr>
-          <a:xfrm>
-            <a:off x="548640" y="2377440"/>
-            <a:ext cx="10972800" cy="320040"/>
-          </a:xfrm>
-          <a:prstGeom prst="rect">
-            <a:avLst/>
-          </a:prstGeom>
-          <a:noFill/>
-          <a:ln/>
-        </p:spPr>
-        <p:txBody>
-          <a:bodyPr wrap="square" lIns="0" tIns="0" rIns="0" bIns="0" rtlCol="0" anchor="ctr"/>
+          <p:cNvPr id="8" name="Text 5"/>
+          <p:cNvSpPr/>
+          <p:nvPr/>
+        </p:nvSpPr>
+        <p:spPr>
+          <a:xfrm>
+            <a:off x="6355080" y="5074920"/>
+            <a:ext cx="5349240" cy="685800"/>
+          </a:xfrm>
+          <a:prstGeom prst="rect">
+            <a:avLst/>
+          </a:prstGeom>
+          <a:noFill/>
+          <a:ln/>
+        </p:spPr>
+        <p:txBody>
+          <a:bodyPr wrap="square" lIns="0" tIns="0" rIns="0" bIns="0" rtlCol="0" anchor="t"/>
           <a:lstStyle/>
           <a:p>
             <a:pPr indent="0" marL="0">
               <a:buNone/>
             </a:pPr>
             <a:r>
-              <a:rPr lang="en-US" sz="1300" b="1" dirty="0">
-                <a:solidFill>
-                  <a:srgbClr val="0B3D3D"/>
-                </a:solidFill>
-                <a:latin typeface="Calibri" pitchFamily="34" charset="0"/>
-                <a:ea typeface="Calibri" pitchFamily="34" charset="-122"/>
-                <a:cs typeface="Calibri" pitchFamily="34" charset="-120"/>
-              </a:rPr>
-              <a:t>2.  Inside the table — plain folders, nothing exotic</a:t>
-            </a:r>
-            <a:endParaRPr lang="en-US" sz="1300" dirty="0"/>
-          </a:p>
-        </p:txBody>
-      </p:sp>
-      <p:pic>
-        <p:nvPicPr>
-          <p:cNvPr id="8" name="Image 1" descr="C:/Users/jerem/AppData/Local/Temp/claude/C--claude/ae2a9827-8b94-4dcd-a82b-a6eb63227025/scratchpad/redacted-gcs_bucket_for__iceberg_zero_copy_path.png">    </p:cNvPr>
-          <p:cNvPicPr>
-            <a:picLocks noChangeAspect="1"/>
-          </p:cNvPicPr>
-          <p:nvPr/>
-        </p:nvPicPr>
-        <p:blipFill>
-          <a:blip r:embed="rId2"/>
-          <a:srcRect l="0" r="0" t="0" b="0"/>
-          <a:stretch/>
-        </p:blipFill>
-        <p:spPr>
-          <a:xfrm>
-            <a:off x="548640" y="2788920"/>
-            <a:ext cx="4480560" cy="1460747"/>
-          </a:xfrm>
-          <a:prstGeom prst="rect">
-            <a:avLst/>
-          </a:prstGeom>
-        </p:spPr>
-      </p:pic>
-      <p:sp>
-        <p:nvSpPr>
-          <p:cNvPr id="9" name="Shape 5"/>
-          <p:cNvSpPr/>
-          <p:nvPr/>
-        </p:nvSpPr>
-        <p:spPr>
-          <a:xfrm>
-            <a:off x="5577840" y="2788920"/>
-            <a:ext cx="6080760" cy="1460747"/>
-          </a:xfrm>
-          <a:prstGeom prst="roundRect">
-            <a:avLst>
-              <a:gd name="adj" fmla="val 3756"/>
-            </a:avLst>
-          </a:prstGeom>
-          <a:solidFill>
-            <a:srgbClr val="F4F4F3"/>
-          </a:solidFill>
-          <a:ln w="17780">
-            <a:solidFill>
-              <a:srgbClr val="D8D8D6"/>
-            </a:solidFill>
-            <a:prstDash val="solid"/>
-          </a:ln>
-        </p:spPr>
-      </p:sp>
-      <p:sp>
-        <p:nvSpPr>
-          <p:cNvPr id="10" name="Text 6"/>
-          <p:cNvSpPr/>
-          <p:nvPr/>
-        </p:nvSpPr>
-        <p:spPr>
-          <a:xfrm>
-            <a:off x="5806440" y="2788920"/>
-            <a:ext cx="5623560" cy="1460747"/>
-          </a:xfrm>
-          <a:prstGeom prst="rect">
-            <a:avLst/>
-          </a:prstGeom>
-          <a:noFill/>
-          <a:ln/>
-        </p:spPr>
-        <p:txBody>
-          <a:bodyPr wrap="square" lIns="1270" tIns="1270" rIns="1270" bIns="1270" rtlCol="0" anchor="ctr"/>
-          <a:lstStyle/>
-          <a:p>
-            <a:pPr indent="0" marL="0">
-              <a:buNone/>
-            </a:pPr>
-            <a:r>
-              <a:rPr lang="en-US" sz="1300" dirty="0">
-                <a:solidFill>
-                  <a:srgbClr val="1A2E2E"/>
-                </a:solidFill>
-                <a:latin typeface="Calibri" pitchFamily="34" charset="0"/>
-                <a:ea typeface="Calibri" pitchFamily="34" charset="-122"/>
-                <a:cs typeface="Calibri" pitchFamily="34" charset="-120"/>
-              </a:rPr>
-              <a:t>That is the entire trick of an open table format: Parquet data plus enough metadata for a remote engine to discover schema and file locations on its own — no proprietary handshake, no per-engine connector.</a:t>
-            </a:r>
-            <a:endParaRPr lang="en-US" sz="1300" dirty="0"/>
+              <a:rPr lang="en-US" sz="1150" i="1" dirty="0">
+                <a:solidFill>
+                  <a:srgbClr val="5B6B6B"/>
+                </a:solidFill>
+                <a:latin typeface="Calibri" pitchFamily="34" charset="0"/>
+                <a:ea typeface="Calibri" pitchFamily="34" charset="-122"/>
+                <a:cs typeface="Calibri" pitchFamily="34" charset="-120"/>
+              </a:rPr>
+              <a:t>After the write: metadata/ and data/ — a plain, open Iceberg table.</a:t>
+            </a:r>
+            <a:endParaRPr lang="en-US" sz="1150" dirty="0"/>
           </a:p>
         </p:txBody>
       </p:sp>
@@ -5989,7 +5897,7 @@
                 <a:ea typeface="Cambria" pitchFamily="34" charset="-122"/>
                 <a:cs typeface="Cambria" pitchFamily="34" charset="-120"/>
               </a:rPr>
-              <a:t>Appendix C — Proof: Registered &amp; Trusted</a:t>
+              <a:t>Appendix  ·  Step 3 of 5 — Keyless Trust (WIF)</a:t>
             </a:r>
             <a:endParaRPr lang="en-US" sz="2800" dirty="0"/>
           </a:p>
@@ -6028,7 +5936,7 @@
                 <a:ea typeface="Calibri" pitchFamily="34" charset="-122"/>
                 <a:cs typeface="Calibri" pitchFamily="34" charset="-120"/>
               </a:rPr>
-              <a:t>The table is live in the catalog; the cross-cloud trust is real and firing</a:t>
+              <a:t>Snowflake's issuer becomes a GCP workload-identity pool; no key is ever shipped</a:t>
             </a:r>
             <a:endParaRPr lang="en-US" sz="1400" dirty="0"/>
           </a:p>
@@ -6075,46 +5983,314 @@
       </p:sp>
       <p:sp>
         <p:nvSpPr>
-          <p:cNvPr id="5" name="Text 3"/>
-          <p:cNvSpPr/>
-          <p:nvPr/>
-        </p:nvSpPr>
-        <p:spPr>
-          <a:xfrm>
-            <a:off x="548640" y="1234440"/>
-            <a:ext cx="10972800" cy="320040"/>
-          </a:xfrm>
-          <a:prstGeom prst="rect">
-            <a:avLst/>
-          </a:prstGeom>
-          <a:noFill/>
-          <a:ln/>
-        </p:spPr>
-        <p:txBody>
-          <a:bodyPr wrap="square" lIns="0" tIns="0" rIns="0" bIns="0" rtlCol="0" anchor="ctr"/>
-          <a:lstStyle/>
-          <a:p>
-            <a:pPr indent="0" marL="0">
-              <a:buNone/>
-            </a:pPr>
-            <a:r>
-              <a:rPr lang="en-US" sz="1300" b="1" dirty="0">
-                <a:solidFill>
-                  <a:srgbClr val="0B3D3D"/>
-                </a:solidFill>
-                <a:latin typeface="Calibri" pitchFamily="34" charset="0"/>
-                <a:ea typeface="Calibri" pitchFamily="34" charset="-122"/>
-                <a:cs typeface="Calibri" pitchFamily="34" charset="-120"/>
-              </a:rPr>
-              <a:t>3.  Registered in BigLake — and queryable from within GCP</a:t>
-            </a:r>
-            <a:endParaRPr lang="en-US" sz="1300" dirty="0"/>
+          <p:cNvPr id="5" name="Shape 3"/>
+          <p:cNvSpPr/>
+          <p:nvPr/>
+        </p:nvSpPr>
+        <p:spPr>
+          <a:xfrm>
+            <a:off x="548640" y="1371600"/>
+            <a:ext cx="5623560" cy="4297680"/>
+          </a:xfrm>
+          <a:prstGeom prst="roundRect">
+            <a:avLst>
+              <a:gd name="adj" fmla="val 1064"/>
+            </a:avLst>
+          </a:prstGeom>
+          <a:solidFill>
+            <a:srgbClr val="0E2A2A"/>
+          </a:solidFill>
+          <a:ln w="12700">
+            <a:solidFill>
+              <a:srgbClr val="0E2A2A"/>
+            </a:solidFill>
+            <a:prstDash val="solid"/>
+          </a:ln>
+        </p:spPr>
+      </p:sp>
+      <p:sp>
+        <p:nvSpPr>
+          <p:cNvPr id="6" name="Text 4"/>
+          <p:cNvSpPr/>
+          <p:nvPr/>
+        </p:nvSpPr>
+        <p:spPr>
+          <a:xfrm>
+            <a:off x="713232" y="1499616"/>
+            <a:ext cx="5294376" cy="4041648"/>
+          </a:xfrm>
+          <a:prstGeom prst="rect">
+            <a:avLst/>
+          </a:prstGeom>
+          <a:noFill/>
+          <a:ln/>
+        </p:spPr>
+        <p:txBody>
+          <a:bodyPr wrap="square" lIns="0" tIns="0" rIns="0" bIns="0" rtlCol="0" anchor="t"/>
+          <a:lstStyle/>
+          <a:p>
+            <a:pPr algn="l" indent="0" marL="0">
+              <a:lnSpc>
+                <a:spcPct val="105000"/>
+              </a:lnSpc>
+              <a:buNone/>
+            </a:pPr>
+            <a:r>
+              <a:rPr lang="en-US" sz="950" dirty="0">
+                <a:solidFill>
+                  <a:srgbClr val="CFE8E6"/>
+                </a:solidFill>
+                <a:latin typeface="Courier New" pitchFamily="34" charset="0"/>
+                <a:ea typeface="Courier New" pitchFamily="34" charset="-122"/>
+                <a:cs typeface="Courier New" pitchFamily="34" charset="-120"/>
+              </a:rPr>
+              <a:t># issuer URL from Snowflake:</a:t>
+            </a:r>
+            <a:endParaRPr lang="en-US" sz="950" dirty="0"/>
+          </a:p>
+          <a:p>
+            <a:pPr algn="l" indent="0" marL="0">
+              <a:lnSpc>
+                <a:spcPct val="105000"/>
+              </a:lnSpc>
+              <a:buNone/>
+            </a:pPr>
+            <a:r>
+              <a:rPr lang="en-US" sz="950" dirty="0">
+                <a:solidFill>
+                  <a:srgbClr val="CFE8E6"/>
+                </a:solidFill>
+                <a:latin typeface="Courier New" pitchFamily="34" charset="0"/>
+                <a:ea typeface="Courier New" pitchFamily="34" charset="-122"/>
+                <a:cs typeface="Courier New" pitchFamily="34" charset="-120"/>
+              </a:rPr>
+              <a:t>#   SELECT SYSTEM$GET_WORKLOAD_</a:t>
+            </a:r>
+            <a:endParaRPr lang="en-US" sz="950" dirty="0"/>
+          </a:p>
+          <a:p>
+            <a:pPr algn="l" indent="0" marL="0">
+              <a:lnSpc>
+                <a:spcPct val="105000"/>
+              </a:lnSpc>
+              <a:buNone/>
+            </a:pPr>
+            <a:r>
+              <a:rPr lang="en-US" sz="950" dirty="0">
+                <a:solidFill>
+                  <a:srgbClr val="CFE8E6"/>
+                </a:solidFill>
+                <a:latin typeface="Courier New" pitchFamily="34" charset="0"/>
+                <a:ea typeface="Courier New" pitchFamily="34" charset="-122"/>
+                <a:cs typeface="Courier New" pitchFamily="34" charset="-120"/>
+              </a:rPr>
+              <a:t>#          IDENTITY_ISSUER_URL();</a:t>
+            </a:r>
+            <a:endParaRPr lang="en-US" sz="950" dirty="0"/>
+          </a:p>
+          <a:p>
+            <a:pPr algn="l" indent="0" marL="0">
+              <a:lnSpc>
+                <a:spcPct val="105000"/>
+              </a:lnSpc>
+              <a:buNone/>
+            </a:pPr>
+            <a:endParaRPr lang="en-US" sz="950" dirty="0"/>
+          </a:p>
+          <a:p>
+            <a:pPr algn="l" indent="0" marL="0">
+              <a:lnSpc>
+                <a:spcPct val="105000"/>
+              </a:lnSpc>
+              <a:buNone/>
+            </a:pPr>
+            <a:r>
+              <a:rPr lang="en-US" sz="950" dirty="0">
+                <a:solidFill>
+                  <a:srgbClr val="CFE8E6"/>
+                </a:solidFill>
+                <a:latin typeface="Courier New" pitchFamily="34" charset="0"/>
+                <a:ea typeface="Courier New" pitchFamily="34" charset="-122"/>
+                <a:cs typeface="Courier New" pitchFamily="34" charset="-120"/>
+              </a:rPr>
+              <a:t>gcloud iam workload-identity-pools \</a:t>
+            </a:r>
+            <a:endParaRPr lang="en-US" sz="950" dirty="0"/>
+          </a:p>
+          <a:p>
+            <a:pPr algn="l" indent="0" marL="0">
+              <a:lnSpc>
+                <a:spcPct val="105000"/>
+              </a:lnSpc>
+              <a:buNone/>
+            </a:pPr>
+            <a:r>
+              <a:rPr lang="en-US" sz="950" dirty="0">
+                <a:solidFill>
+                  <a:srgbClr val="CFE8E6"/>
+                </a:solidFill>
+                <a:latin typeface="Courier New" pitchFamily="34" charset="0"/>
+                <a:ea typeface="Courier New" pitchFamily="34" charset="-122"/>
+                <a:cs typeface="Courier New" pitchFamily="34" charset="-120"/>
+              </a:rPr>
+              <a:t>  create $POOL_ID --location global</a:t>
+            </a:r>
+            <a:endParaRPr lang="en-US" sz="950" dirty="0"/>
+          </a:p>
+          <a:p>
+            <a:pPr algn="l" indent="0" marL="0">
+              <a:lnSpc>
+                <a:spcPct val="105000"/>
+              </a:lnSpc>
+              <a:buNone/>
+            </a:pPr>
+            <a:endParaRPr lang="en-US" sz="950" dirty="0"/>
+          </a:p>
+          <a:p>
+            <a:pPr algn="l" indent="0" marL="0">
+              <a:lnSpc>
+                <a:spcPct val="105000"/>
+              </a:lnSpc>
+              <a:buNone/>
+            </a:pPr>
+            <a:r>
+              <a:rPr lang="en-US" sz="950" dirty="0">
+                <a:solidFill>
+                  <a:srgbClr val="CFE8E6"/>
+                </a:solidFill>
+                <a:latin typeface="Courier New" pitchFamily="34" charset="0"/>
+                <a:ea typeface="Courier New" pitchFamily="34" charset="-122"/>
+                <a:cs typeface="Courier New" pitchFamily="34" charset="-120"/>
+              </a:rPr>
+              <a:t>gcloud iam workload-identity-pools \</a:t>
+            </a:r>
+            <a:endParaRPr lang="en-US" sz="950" dirty="0"/>
+          </a:p>
+          <a:p>
+            <a:pPr algn="l" indent="0" marL="0">
+              <a:lnSpc>
+                <a:spcPct val="105000"/>
+              </a:lnSpc>
+              <a:buNone/>
+            </a:pPr>
+            <a:r>
+              <a:rPr lang="en-US" sz="950" dirty="0">
+                <a:solidFill>
+                  <a:srgbClr val="CFE8E6"/>
+                </a:solidFill>
+                <a:latin typeface="Courier New" pitchFamily="34" charset="0"/>
+                <a:ea typeface="Courier New" pitchFamily="34" charset="-122"/>
+                <a:cs typeface="Courier New" pitchFamily="34" charset="-120"/>
+              </a:rPr>
+              <a:t>  providers create-oidc $PROVIDER_ID \</a:t>
+            </a:r>
+            <a:endParaRPr lang="en-US" sz="950" dirty="0"/>
+          </a:p>
+          <a:p>
+            <a:pPr algn="l" indent="0" marL="0">
+              <a:lnSpc>
+                <a:spcPct val="105000"/>
+              </a:lnSpc>
+              <a:buNone/>
+            </a:pPr>
+            <a:r>
+              <a:rPr lang="en-US" sz="950" dirty="0">
+                <a:solidFill>
+                  <a:srgbClr val="CFE8E6"/>
+                </a:solidFill>
+                <a:latin typeface="Courier New" pitchFamily="34" charset="0"/>
+                <a:ea typeface="Courier New" pitchFamily="34" charset="-122"/>
+                <a:cs typeface="Courier New" pitchFamily="34" charset="-120"/>
+              </a:rPr>
+              <a:t>  --workload-identity-pool $POOL_ID \</a:t>
+            </a:r>
+            <a:endParaRPr lang="en-US" sz="950" dirty="0"/>
+          </a:p>
+          <a:p>
+            <a:pPr algn="l" indent="0" marL="0">
+              <a:lnSpc>
+                <a:spcPct val="105000"/>
+              </a:lnSpc>
+              <a:buNone/>
+            </a:pPr>
+            <a:r>
+              <a:rPr lang="en-US" sz="950" dirty="0">
+                <a:solidFill>
+                  <a:srgbClr val="CFE8E6"/>
+                </a:solidFill>
+                <a:latin typeface="Courier New" pitchFamily="34" charset="0"/>
+                <a:ea typeface="Courier New" pitchFamily="34" charset="-122"/>
+                <a:cs typeface="Courier New" pitchFamily="34" charset="-120"/>
+              </a:rPr>
+              <a:t>  --location global \</a:t>
+            </a:r>
+            <a:endParaRPr lang="en-US" sz="950" dirty="0"/>
+          </a:p>
+          <a:p>
+            <a:pPr algn="l" indent="0" marL="0">
+              <a:lnSpc>
+                <a:spcPct val="105000"/>
+              </a:lnSpc>
+              <a:buNone/>
+            </a:pPr>
+            <a:r>
+              <a:rPr lang="en-US" sz="950" dirty="0">
+                <a:solidFill>
+                  <a:srgbClr val="CFE8E6"/>
+                </a:solidFill>
+                <a:latin typeface="Courier New" pitchFamily="34" charset="0"/>
+                <a:ea typeface="Courier New" pitchFamily="34" charset="-122"/>
+                <a:cs typeface="Courier New" pitchFamily="34" charset="-120"/>
+              </a:rPr>
+              <a:t>  --issuer-uri "&lt;ISSUER_URL&gt;" \</a:t>
+            </a:r>
+            <a:endParaRPr lang="en-US" sz="950" dirty="0"/>
+          </a:p>
+          <a:p>
+            <a:pPr algn="l" indent="0" marL="0">
+              <a:lnSpc>
+                <a:spcPct val="105000"/>
+              </a:lnSpc>
+              <a:buNone/>
+            </a:pPr>
+            <a:r>
+              <a:rPr lang="en-US" sz="950" dirty="0">
+                <a:solidFill>
+                  <a:srgbClr val="CFE8E6"/>
+                </a:solidFill>
+                <a:latin typeface="Courier New" pitchFamily="34" charset="0"/>
+                <a:ea typeface="Courier New" pitchFamily="34" charset="-122"/>
+                <a:cs typeface="Courier New" pitchFamily="34" charset="-120"/>
+              </a:rPr>
+              <a:t>  --attribute-mapping \</a:t>
+            </a:r>
+            <a:endParaRPr lang="en-US" sz="950" dirty="0"/>
+          </a:p>
+          <a:p>
+            <a:pPr algn="l" indent="0" marL="0">
+              <a:lnSpc>
+                <a:spcPct val="105000"/>
+              </a:lnSpc>
+              <a:buNone/>
+            </a:pPr>
+            <a:r>
+              <a:rPr lang="en-US" sz="950" dirty="0">
+                <a:solidFill>
+                  <a:srgbClr val="CFE8E6"/>
+                </a:solidFill>
+                <a:latin typeface="Courier New" pitchFamily="34" charset="0"/>
+                <a:ea typeface="Courier New" pitchFamily="34" charset="-122"/>
+                <a:cs typeface="Courier New" pitchFamily="34" charset="-120"/>
+              </a:rPr>
+              <a:t>    "google.subject=assertion.sub"</a:t>
+            </a:r>
+            <a:endParaRPr lang="en-US" sz="950" dirty="0"/>
           </a:p>
         </p:txBody>
       </p:sp>
       <p:pic>
         <p:nvPicPr>
-          <p:cNvPr id="6" name="Image 0" descr="C:/Users/jerem/AppData/Local/Temp/claude/C--claude/ae2a9827-8b94-4dcd-a82b-a6eb63227025/scratchpad/redacted-gcp_iceberg_table_registed_in_biglake.png">    </p:cNvPr>
+          <p:cNvPr id="7" name="Image 0" descr="C:/Users/jerem/Desktop/zc/gcp_wif_for_snowflake_connection.png">    </p:cNvPr>
           <p:cNvPicPr>
             <a:picLocks noChangeAspect="1"/>
           </p:cNvPicPr>
@@ -6128,8 +6304,8 @@
         </p:blipFill>
         <p:spPr>
           <a:xfrm>
-            <a:off x="548640" y="1645920"/>
-            <a:ext cx="8229600" cy="1049015"/>
+            <a:off x="6355080" y="2053757"/>
+            <a:ext cx="5394960" cy="2201845"/>
           </a:xfrm>
           <a:prstGeom prst="rect">
             <a:avLst/>
@@ -6138,130 +6314,40 @@
       </p:pic>
       <p:sp>
         <p:nvSpPr>
-          <p:cNvPr id="7" name="Text 4"/>
-          <p:cNvSpPr/>
-          <p:nvPr/>
-        </p:nvSpPr>
-        <p:spPr>
-          <a:xfrm>
-            <a:off x="548640" y="2834640"/>
-            <a:ext cx="10972800" cy="320040"/>
-          </a:xfrm>
-          <a:prstGeom prst="rect">
-            <a:avLst/>
-          </a:prstGeom>
-          <a:noFill/>
-          <a:ln/>
-        </p:spPr>
-        <p:txBody>
-          <a:bodyPr wrap="square" lIns="0" tIns="0" rIns="0" bIns="0" rtlCol="0" anchor="ctr"/>
+          <p:cNvPr id="8" name="Text 5"/>
+          <p:cNvSpPr/>
+          <p:nvPr/>
+        </p:nvSpPr>
+        <p:spPr>
+          <a:xfrm>
+            <a:off x="6355080" y="5074920"/>
+            <a:ext cx="5349240" cy="685800"/>
+          </a:xfrm>
+          <a:prstGeom prst="rect">
+            <a:avLst/>
+          </a:prstGeom>
+          <a:noFill/>
+          <a:ln/>
+        </p:spPr>
+        <p:txBody>
+          <a:bodyPr wrap="square" lIns="0" tIns="0" rIns="0" bIns="0" rtlCol="0" anchor="t"/>
           <a:lstStyle/>
           <a:p>
             <a:pPr indent="0" marL="0">
               <a:buNone/>
             </a:pPr>
             <a:r>
-              <a:rPr lang="en-US" sz="1300" b="1" dirty="0">
-                <a:solidFill>
-                  <a:srgbClr val="0B3D3D"/>
-                </a:solidFill>
-                <a:latin typeface="Calibri" pitchFamily="34" charset="0"/>
-                <a:ea typeface="Calibri" pitchFamily="34" charset="-122"/>
-                <a:cs typeface="Calibri" pitchFamily="34" charset="-120"/>
-              </a:rPr>
-              <a:t>4.  Workload Identity Federation — live token exchanges, not idle config</a:t>
-            </a:r>
-            <a:endParaRPr lang="en-US" sz="1300" dirty="0"/>
-          </a:p>
-        </p:txBody>
-      </p:sp>
-      <p:pic>
-        <p:nvPicPr>
-          <p:cNvPr id="8" name="Image 1" descr="C:/Users/jerem/Desktop/zc/gcp_wif_for_snowflake_connection.png">    </p:cNvPr>
-          <p:cNvPicPr>
-            <a:picLocks noChangeAspect="1"/>
-          </p:cNvPicPr>
-          <p:nvPr/>
-        </p:nvPicPr>
-        <p:blipFill>
-          <a:blip r:embed="rId2"/>
-          <a:stretch>
-            <a:fillRect/>
-          </a:stretch>
-        </p:blipFill>
-        <p:spPr>
-          <a:xfrm>
-            <a:off x="548640" y="3246120"/>
-            <a:ext cx="4663440" cy="1903290"/>
-          </a:xfrm>
-          <a:prstGeom prst="rect">
-            <a:avLst/>
-          </a:prstGeom>
-        </p:spPr>
-      </p:pic>
-      <p:sp>
-        <p:nvSpPr>
-          <p:cNvPr id="9" name="Shape 5"/>
-          <p:cNvSpPr/>
-          <p:nvPr/>
-        </p:nvSpPr>
-        <p:spPr>
-          <a:xfrm>
-            <a:off x="5486400" y="3246120"/>
-            <a:ext cx="6172200" cy="1903290"/>
-          </a:xfrm>
-          <a:prstGeom prst="roundRect">
-            <a:avLst>
-              <a:gd name="adj" fmla="val 2883"/>
-            </a:avLst>
-          </a:prstGeom>
-          <a:solidFill>
-            <a:srgbClr val="F4F4F3"/>
-          </a:solidFill>
-          <a:ln w="17780">
-            <a:solidFill>
-              <a:srgbClr val="D8D8D6"/>
-            </a:solidFill>
-            <a:prstDash val="solid"/>
-          </a:ln>
-        </p:spPr>
-      </p:sp>
-      <p:sp>
-        <p:nvSpPr>
-          <p:cNvPr id="10" name="Text 6"/>
-          <p:cNvSpPr/>
-          <p:nvPr/>
-        </p:nvSpPr>
-        <p:spPr>
-          <a:xfrm>
-            <a:off x="5715000" y="3246120"/>
-            <a:ext cx="5715000" cy="1903290"/>
-          </a:xfrm>
-          <a:prstGeom prst="rect">
-            <a:avLst/>
-          </a:prstGeom>
-          <a:noFill/>
-          <a:ln/>
-        </p:spPr>
-        <p:txBody>
-          <a:bodyPr wrap="square" lIns="1270" tIns="1270" rIns="1270" bIns="1270" rtlCol="0" anchor="ctr"/>
-          <a:lstStyle/>
-          <a:p>
-            <a:pPr indent="0" marL="0">
-              <a:buNone/>
-            </a:pPr>
-            <a:r>
-              <a:rPr lang="en-US" sz="1300" dirty="0">
-                <a:solidFill>
-                  <a:srgbClr val="1A2E2E"/>
-                </a:solidFill>
-                <a:latin typeface="Calibri" pitchFamily="34" charset="0"/>
-                <a:ea typeface="Calibri" pitchFamily="34" charset="-122"/>
-                <a:cs typeface="Calibri" pitchFamily="34" charset="-120"/>
-              </a:rPr>
-              <a:t>Each Snowflake query drives a fresh token exchange through the identity pool. There is no service-account key stored anywhere — the trust is established per request and expires.</a:t>
-            </a:r>
-            <a:endParaRPr lang="en-US" sz="1300" dirty="0"/>
+              <a:rPr lang="en-US" sz="1150" i="1" dirty="0">
+                <a:solidFill>
+                  <a:srgbClr val="5B6B6B"/>
+                </a:solidFill>
+                <a:latin typeface="Calibri" pitchFamily="34" charset="0"/>
+                <a:ea typeface="Calibri" pitchFamily="34" charset="-122"/>
+                <a:cs typeface="Calibri" pitchFamily="34" charset="-120"/>
+              </a:rPr>
+              <a:t>The pool, active — a token exchange fires on every query.</a:t>
+            </a:r>
+            <a:endParaRPr lang="en-US" sz="1150" dirty="0"/>
           </a:p>
         </p:txBody>
       </p:sp>
@@ -6330,7 +6416,7 @@
                 <a:ea typeface="Cambria" pitchFamily="34" charset="-122"/>
                 <a:cs typeface="Cambria" pitchFamily="34" charset="-120"/>
               </a:rPr>
-              <a:t>Appendix D — Proof: The Payoff</a:t>
+              <a:t>Appendix  ·  Step 4 of 5 — Catalog Integration</a:t>
             </a:r>
             <a:endParaRPr lang="en-US" sz="2800" dirty="0"/>
           </a:p>
@@ -6369,7 +6455,7 @@
                 <a:ea typeface="Calibri" pitchFamily="34" charset="-122"/>
                 <a:cs typeface="Calibri" pitchFamily="34" charset="-120"/>
               </a:rPr>
-              <a:t>A plain SELECT in Snowflake, reading GCS-resident data live</a:t>
+              <a:t>On the Snowflake side: a token-exchange integration against the same catalog</a:t>
             </a:r>
             <a:endParaRPr lang="en-US" sz="1400" dirty="0"/>
           </a:p>
@@ -6414,9 +6500,318 @@
           </a:p>
         </p:txBody>
       </p:sp>
+      <p:sp>
+        <p:nvSpPr>
+          <p:cNvPr id="5" name="Shape 3"/>
+          <p:cNvSpPr/>
+          <p:nvPr/>
+        </p:nvSpPr>
+        <p:spPr>
+          <a:xfrm>
+            <a:off x="548640" y="1371600"/>
+            <a:ext cx="5623560" cy="4297680"/>
+          </a:xfrm>
+          <a:prstGeom prst="roundRect">
+            <a:avLst>
+              <a:gd name="adj" fmla="val 1064"/>
+            </a:avLst>
+          </a:prstGeom>
+          <a:solidFill>
+            <a:srgbClr val="0E2A2A"/>
+          </a:solidFill>
+          <a:ln w="12700">
+            <a:solidFill>
+              <a:srgbClr val="0E2A2A"/>
+            </a:solidFill>
+            <a:prstDash val="solid"/>
+          </a:ln>
+        </p:spPr>
+      </p:sp>
+      <p:sp>
+        <p:nvSpPr>
+          <p:cNvPr id="6" name="Text 4"/>
+          <p:cNvSpPr/>
+          <p:nvPr/>
+        </p:nvSpPr>
+        <p:spPr>
+          <a:xfrm>
+            <a:off x="713232" y="1499616"/>
+            <a:ext cx="5294376" cy="4041648"/>
+          </a:xfrm>
+          <a:prstGeom prst="rect">
+            <a:avLst/>
+          </a:prstGeom>
+          <a:noFill/>
+          <a:ln/>
+        </p:spPr>
+        <p:txBody>
+          <a:bodyPr wrap="square" lIns="0" tIns="0" rIns="0" bIns="0" rtlCol="0" anchor="t"/>
+          <a:lstStyle/>
+          <a:p>
+            <a:pPr algn="l" indent="0" marL="0">
+              <a:lnSpc>
+                <a:spcPct val="105000"/>
+              </a:lnSpc>
+              <a:buNone/>
+            </a:pPr>
+            <a:r>
+              <a:rPr lang="en-US" sz="950" dirty="0">
+                <a:solidFill>
+                  <a:srgbClr val="CFE8E6"/>
+                </a:solidFill>
+                <a:latin typeface="Courier New" pitchFamily="34" charset="0"/>
+                <a:ea typeface="Courier New" pitchFamily="34" charset="-122"/>
+                <a:cs typeface="Courier New" pitchFamily="34" charset="-120"/>
+              </a:rPr>
+              <a:t>CREATE OR REPLACE CATALOG INTEGRATION</a:t>
+            </a:r>
+            <a:endParaRPr lang="en-US" sz="950" dirty="0"/>
+          </a:p>
+          <a:p>
+            <a:pPr algn="l" indent="0" marL="0">
+              <a:lnSpc>
+                <a:spcPct val="105000"/>
+              </a:lnSpc>
+              <a:buNone/>
+            </a:pPr>
+            <a:r>
+              <a:rPr lang="en-US" sz="950" dirty="0">
+                <a:solidFill>
+                  <a:srgbClr val="CFE8E6"/>
+                </a:solidFill>
+                <a:latin typeface="Courier New" pitchFamily="34" charset="0"/>
+                <a:ea typeface="Courier New" pitchFamily="34" charset="-122"/>
+                <a:cs typeface="Courier New" pitchFamily="34" charset="-120"/>
+              </a:rPr>
+              <a:t>    biglake_int</a:t>
+            </a:r>
+            <a:endParaRPr lang="en-US" sz="950" dirty="0"/>
+          </a:p>
+          <a:p>
+            <a:pPr algn="l" indent="0" marL="0">
+              <a:lnSpc>
+                <a:spcPct val="105000"/>
+              </a:lnSpc>
+              <a:buNone/>
+            </a:pPr>
+            <a:r>
+              <a:rPr lang="en-US" sz="950" dirty="0">
+                <a:solidFill>
+                  <a:srgbClr val="CFE8E6"/>
+                </a:solidFill>
+                <a:latin typeface="Courier New" pitchFamily="34" charset="0"/>
+                <a:ea typeface="Courier New" pitchFamily="34" charset="-122"/>
+                <a:cs typeface="Courier New" pitchFamily="34" charset="-120"/>
+              </a:rPr>
+              <a:t>  CATALOG_SOURCE = ICEBERG_REST</a:t>
+            </a:r>
+            <a:endParaRPr lang="en-US" sz="950" dirty="0"/>
+          </a:p>
+          <a:p>
+            <a:pPr algn="l" indent="0" marL="0">
+              <a:lnSpc>
+                <a:spcPct val="105000"/>
+              </a:lnSpc>
+              <a:buNone/>
+            </a:pPr>
+            <a:r>
+              <a:rPr lang="en-US" sz="950" dirty="0">
+                <a:solidFill>
+                  <a:srgbClr val="CFE8E6"/>
+                </a:solidFill>
+                <a:latin typeface="Courier New" pitchFamily="34" charset="0"/>
+                <a:ea typeface="Courier New" pitchFamily="34" charset="-122"/>
+                <a:cs typeface="Courier New" pitchFamily="34" charset="-120"/>
+              </a:rPr>
+              <a:t>  TABLE_FORMAT   = ICEBERG</a:t>
+            </a:r>
+            <a:endParaRPr lang="en-US" sz="950" dirty="0"/>
+          </a:p>
+          <a:p>
+            <a:pPr algn="l" indent="0" marL="0">
+              <a:lnSpc>
+                <a:spcPct val="105000"/>
+              </a:lnSpc>
+              <a:buNone/>
+            </a:pPr>
+            <a:r>
+              <a:rPr lang="en-US" sz="950" dirty="0">
+                <a:solidFill>
+                  <a:srgbClr val="CFE8E6"/>
+                </a:solidFill>
+                <a:latin typeface="Courier New" pitchFamily="34" charset="0"/>
+                <a:ea typeface="Courier New" pitchFamily="34" charset="-122"/>
+                <a:cs typeface="Courier New" pitchFamily="34" charset="-120"/>
+              </a:rPr>
+              <a:t>  REST_CONFIG = (</a:t>
+            </a:r>
+            <a:endParaRPr lang="en-US" sz="950" dirty="0"/>
+          </a:p>
+          <a:p>
+            <a:pPr algn="l" indent="0" marL="0">
+              <a:lnSpc>
+                <a:spcPct val="105000"/>
+              </a:lnSpc>
+              <a:buNone/>
+            </a:pPr>
+            <a:r>
+              <a:rPr lang="en-US" sz="950" dirty="0">
+                <a:solidFill>
+                  <a:srgbClr val="CFE8E6"/>
+                </a:solidFill>
+                <a:latin typeface="Courier New" pitchFamily="34" charset="0"/>
+                <a:ea typeface="Courier New" pitchFamily="34" charset="-122"/>
+                <a:cs typeface="Courier New" pitchFamily="34" charset="-120"/>
+              </a:rPr>
+              <a:t>    CATALOG_URI  = 'https://biglake...',</a:t>
+            </a:r>
+            <a:endParaRPr lang="en-US" sz="950" dirty="0"/>
+          </a:p>
+          <a:p>
+            <a:pPr algn="l" indent="0" marL="0">
+              <a:lnSpc>
+                <a:spcPct val="105000"/>
+              </a:lnSpc>
+              <a:buNone/>
+            </a:pPr>
+            <a:r>
+              <a:rPr lang="en-US" sz="950" dirty="0">
+                <a:solidFill>
+                  <a:srgbClr val="CFE8E6"/>
+                </a:solidFill>
+                <a:latin typeface="Courier New" pitchFamily="34" charset="0"/>
+                <a:ea typeface="Courier New" pitchFamily="34" charset="-122"/>
+                <a:cs typeface="Courier New" pitchFamily="34" charset="-120"/>
+              </a:rPr>
+              <a:t>    CATALOG_NAME = 'gs://&lt;BUCKET&gt;',</a:t>
+            </a:r>
+            <a:endParaRPr lang="en-US" sz="950" dirty="0"/>
+          </a:p>
+          <a:p>
+            <a:pPr algn="l" indent="0" marL="0">
+              <a:lnSpc>
+                <a:spcPct val="105000"/>
+              </a:lnSpc>
+              <a:buNone/>
+            </a:pPr>
+            <a:r>
+              <a:rPr lang="en-US" sz="950" dirty="0">
+                <a:solidFill>
+                  <a:srgbClr val="CFE8E6"/>
+                </a:solidFill>
+                <a:latin typeface="Courier New" pitchFamily="34" charset="0"/>
+                <a:ea typeface="Courier New" pitchFamily="34" charset="-122"/>
+                <a:cs typeface="Courier New" pitchFamily="34" charset="-120"/>
+              </a:rPr>
+              <a:t>    ACCESS_DELEGATION_MODE =</a:t>
+            </a:r>
+            <a:endParaRPr lang="en-US" sz="950" dirty="0"/>
+          </a:p>
+          <a:p>
+            <a:pPr algn="l" indent="0" marL="0">
+              <a:lnSpc>
+                <a:spcPct val="105000"/>
+              </a:lnSpc>
+              <a:buNone/>
+            </a:pPr>
+            <a:r>
+              <a:rPr lang="en-US" sz="950" dirty="0">
+                <a:solidFill>
+                  <a:srgbClr val="CFE8E6"/>
+                </a:solidFill>
+                <a:latin typeface="Courier New" pitchFamily="34" charset="0"/>
+                <a:ea typeface="Courier New" pitchFamily="34" charset="-122"/>
+                <a:cs typeface="Courier New" pitchFamily="34" charset="-120"/>
+              </a:rPr>
+              <a:t>        VENDED_CREDENTIALS )</a:t>
+            </a:r>
+            <a:endParaRPr lang="en-US" sz="950" dirty="0"/>
+          </a:p>
+          <a:p>
+            <a:pPr algn="l" indent="0" marL="0">
+              <a:lnSpc>
+                <a:spcPct val="105000"/>
+              </a:lnSpc>
+              <a:buNone/>
+            </a:pPr>
+            <a:r>
+              <a:rPr lang="en-US" sz="950" dirty="0">
+                <a:solidFill>
+                  <a:srgbClr val="CFE8E6"/>
+                </a:solidFill>
+                <a:latin typeface="Courier New" pitchFamily="34" charset="0"/>
+                <a:ea typeface="Courier New" pitchFamily="34" charset="-122"/>
+                <a:cs typeface="Courier New" pitchFamily="34" charset="-120"/>
+              </a:rPr>
+              <a:t>  REST_AUTHENTICATION = (</a:t>
+            </a:r>
+            <a:endParaRPr lang="en-US" sz="950" dirty="0"/>
+          </a:p>
+          <a:p>
+            <a:pPr algn="l" indent="0" marL="0">
+              <a:lnSpc>
+                <a:spcPct val="105000"/>
+              </a:lnSpc>
+              <a:buNone/>
+            </a:pPr>
+            <a:r>
+              <a:rPr lang="en-US" sz="950" dirty="0">
+                <a:solidFill>
+                  <a:srgbClr val="CFE8E6"/>
+                </a:solidFill>
+                <a:latin typeface="Courier New" pitchFamily="34" charset="0"/>
+                <a:ea typeface="Courier New" pitchFamily="34" charset="-122"/>
+                <a:cs typeface="Courier New" pitchFamily="34" charset="-120"/>
+              </a:rPr>
+              <a:t>    TYPE = OAUTH,</a:t>
+            </a:r>
+            <a:endParaRPr lang="en-US" sz="950" dirty="0"/>
+          </a:p>
+          <a:p>
+            <a:pPr algn="l" indent="0" marL="0">
+              <a:lnSpc>
+                <a:spcPct val="105000"/>
+              </a:lnSpc>
+              <a:buNone/>
+            </a:pPr>
+            <a:r>
+              <a:rPr lang="en-US" sz="950" dirty="0">
+                <a:solidFill>
+                  <a:srgbClr val="CFE8E6"/>
+                </a:solidFill>
+                <a:latin typeface="Courier New" pitchFamily="34" charset="0"/>
+                <a:ea typeface="Courier New" pitchFamily="34" charset="-122"/>
+                <a:cs typeface="Courier New" pitchFamily="34" charset="-120"/>
+              </a:rPr>
+              <a:t>    OAUTH_GRANT_TYPE = TOKEN_EXCHANGE...)</a:t>
+            </a:r>
+            <a:endParaRPr lang="en-US" sz="950" dirty="0"/>
+          </a:p>
+          <a:p>
+            <a:pPr algn="l" indent="0" marL="0">
+              <a:lnSpc>
+                <a:spcPct val="105000"/>
+              </a:lnSpc>
+              <a:buNone/>
+            </a:pPr>
+            <a:r>
+              <a:rPr lang="en-US" sz="950" dirty="0">
+                <a:solidFill>
+                  <a:srgbClr val="CFE8E6"/>
+                </a:solidFill>
+                <a:latin typeface="Courier New" pitchFamily="34" charset="0"/>
+                <a:ea typeface="Courier New" pitchFamily="34" charset="-122"/>
+                <a:cs typeface="Courier New" pitchFamily="34" charset="-120"/>
+              </a:rPr>
+              <a:t>  ENABLED = TRUE;</a:t>
+            </a:r>
+            <a:endParaRPr lang="en-US" sz="950" dirty="0"/>
+          </a:p>
+        </p:txBody>
+      </p:sp>
       <p:pic>
         <p:nvPicPr>
-          <p:cNvPr id="5" name="Image 0" descr="C:/Users/jerem/Desktop/zc/data_zero_copy_snowflake_side.png">    </p:cNvPr>
+          <p:cNvPr id="7" name="Image 0" descr="C:/Users/jerem/AppData/Local/Temp/claude/C--claude/ae2a9827-8b94-4dcd-a82b-a6eb63227025/scratchpad/redacted-gcp_iceberg_table_registed_in_biglake.png">    </p:cNvPr>
           <p:cNvPicPr>
             <a:picLocks noChangeAspect="1"/>
           </p:cNvPicPr>
@@ -6430,36 +6825,692 @@
         </p:blipFill>
         <p:spPr>
           <a:xfrm>
+            <a:off x="6355080" y="2810836"/>
+            <a:ext cx="5394960" cy="687688"/>
+          </a:xfrm>
+          <a:prstGeom prst="rect">
+            <a:avLst/>
+          </a:prstGeom>
+        </p:spPr>
+      </p:pic>
+      <p:sp>
+        <p:nvSpPr>
+          <p:cNvPr id="8" name="Text 5"/>
+          <p:cNvSpPr/>
+          <p:nvPr/>
+        </p:nvSpPr>
+        <p:spPr>
+          <a:xfrm>
+            <a:off x="6355080" y="5074920"/>
+            <a:ext cx="5349240" cy="685800"/>
+          </a:xfrm>
+          <a:prstGeom prst="rect">
+            <a:avLst/>
+          </a:prstGeom>
+          <a:noFill/>
+          <a:ln/>
+        </p:spPr>
+        <p:txBody>
+          <a:bodyPr wrap="square" lIns="0" tIns="0" rIns="0" bIns="0" rtlCol="0" anchor="t"/>
+          <a:lstStyle/>
+          <a:p>
+            <a:pPr indent="0" marL="0">
+              <a:buNone/>
+            </a:pPr>
+            <a:r>
+              <a:rPr lang="en-US" sz="1150" i="1" dirty="0">
+                <a:solidFill>
+                  <a:srgbClr val="5B6B6B"/>
+                </a:solidFill>
+                <a:latin typeface="Calibri" pitchFamily="34" charset="0"/>
+                <a:ea typeface="Calibri" pitchFamily="34" charset="-122"/>
+                <a:cs typeface="Calibri" pitchFamily="34" charset="-120"/>
+              </a:rPr>
+              <a:t>The registered table, discoverable through the catalog (here, queried from BigQuery).</a:t>
+            </a:r>
+            <a:endParaRPr lang="en-US" sz="1150" dirty="0"/>
+          </a:p>
+        </p:txBody>
+      </p:sp>
+    </p:spTree>
+  </p:cSld>
+  <p:clrMapOvr>
+    <a:masterClrMapping/>
+  </p:clrMapOvr>
+</p:sld>
+</file>
+
+<file path=ppt/slides/slide18.xml><?xml version="1.0" encoding="utf-8"?>
+<p:sld xmlns:a="http://schemas.openxmlformats.org/drawingml/2006/main" xmlns:r="http://schemas.openxmlformats.org/officeDocument/2006/relationships" xmlns:p="http://schemas.openxmlformats.org/presentationml/2006/main">
+  <p:cSld name="Slide 18">
+    <p:bg>
+      <p:bgPr>
+        <a:solidFill>
+          <a:srgbClr val="F4F4F3"/>
+        </a:solidFill>
+      </p:bgPr>
+    </p:bg>
+    <p:spTree>
+      <p:nvGrpSpPr>
+        <p:cNvPr id="1" name=""/>
+        <p:cNvGrpSpPr/>
+        <p:nvPr/>
+      </p:nvGrpSpPr>
+      <p:grpSpPr>
+        <a:xfrm>
+          <a:off x="0" y="0"/>
+          <a:ext cx="0" cy="0"/>
+          <a:chOff x="0" y="0"/>
+          <a:chExt cx="0" cy="0"/>
+        </a:xfrm>
+      </p:grpSpPr>
+      <p:sp>
+        <p:nvSpPr>
+          <p:cNvPr id="2" name="Text 0"/>
+          <p:cNvSpPr/>
+          <p:nvPr/>
+        </p:nvSpPr>
+        <p:spPr>
+          <a:xfrm>
+            <a:off x="548640" y="274320"/>
+            <a:ext cx="11064240" cy="502920"/>
+          </a:xfrm>
+          <a:prstGeom prst="rect">
+            <a:avLst/>
+          </a:prstGeom>
+          <a:noFill/>
+          <a:ln/>
+        </p:spPr>
+        <p:txBody>
+          <a:bodyPr wrap="square" lIns="0" tIns="0" rIns="0" bIns="0" rtlCol="0" anchor="ctr"/>
+          <a:lstStyle/>
+          <a:p>
+            <a:pPr algn="l" indent="0" marL="0">
+              <a:buNone/>
+            </a:pPr>
+            <a:r>
+              <a:rPr lang="en-US" sz="2800" dirty="0">
+                <a:solidFill>
+                  <a:srgbClr val="0F5C56"/>
+                </a:solidFill>
+                <a:latin typeface="Cambria" pitchFamily="34" charset="0"/>
+                <a:ea typeface="Cambria" pitchFamily="34" charset="-122"/>
+                <a:cs typeface="Cambria" pitchFamily="34" charset="-120"/>
+              </a:rPr>
+              <a:t>Appendix  ·  Step 5 of 5 — Linked DB + Read</a:t>
+            </a:r>
+            <a:endParaRPr lang="en-US" sz="2800" dirty="0"/>
+          </a:p>
+        </p:txBody>
+      </p:sp>
+      <p:sp>
+        <p:nvSpPr>
+          <p:cNvPr id="3" name="Text 1"/>
+          <p:cNvSpPr/>
+          <p:nvPr/>
+        </p:nvSpPr>
+        <p:spPr>
+          <a:xfrm>
+            <a:off x="566928" y="749808"/>
+            <a:ext cx="11064240" cy="365760"/>
+          </a:xfrm>
+          <a:prstGeom prst="rect">
+            <a:avLst/>
+          </a:prstGeom>
+          <a:noFill/>
+          <a:ln/>
+        </p:spPr>
+        <p:txBody>
+          <a:bodyPr wrap="square" lIns="0" tIns="0" rIns="0" bIns="0" rtlCol="0" anchor="ctr"/>
+          <a:lstStyle/>
+          <a:p>
+            <a:pPr indent="0" marL="0">
+              <a:buNone/>
+            </a:pPr>
+            <a:r>
+              <a:rPr lang="en-US" sz="1400" i="1" dirty="0">
+                <a:solidFill>
+                  <a:srgbClr val="1A2E2E"/>
+                </a:solidFill>
+                <a:latin typeface="Calibri" pitchFamily="34" charset="0"/>
+                <a:ea typeface="Calibri" pitchFamily="34" charset="-122"/>
+                <a:cs typeface="Calibri" pitchFamily="34" charset="-120"/>
+              </a:rPr>
+              <a:t>A catalog-linked database, then a plain SELECT — the zero-copy payoff</a:t>
+            </a:r>
+            <a:endParaRPr lang="en-US" sz="1400" dirty="0"/>
+          </a:p>
+        </p:txBody>
+      </p:sp>
+      <p:sp>
+        <p:nvSpPr>
+          <p:cNvPr id="4" name="Text 2"/>
+          <p:cNvSpPr/>
+          <p:nvPr/>
+        </p:nvSpPr>
+        <p:spPr>
+          <a:xfrm>
+            <a:off x="0" y="6583680"/>
+            <a:ext cx="12188952" cy="274320"/>
+          </a:xfrm>
+          <a:prstGeom prst="rect">
+            <a:avLst/>
+          </a:prstGeom>
+          <a:noFill/>
+          <a:ln/>
+        </p:spPr>
+        <p:txBody>
+          <a:bodyPr wrap="square" lIns="0" tIns="0" rIns="0" bIns="0" rtlCol="0" anchor="ctr"/>
+          <a:lstStyle/>
+          <a:p>
+            <a:pPr algn="ctr" indent="0" marL="0">
+              <a:buNone/>
+            </a:pPr>
+            <a:r>
+              <a:rPr lang="en-US" sz="900" dirty="0">
+                <a:solidFill>
+                  <a:srgbClr val="5B6B6B"/>
+                </a:solidFill>
+                <a:latin typeface="Calibri" pitchFamily="34" charset="0"/>
+                <a:ea typeface="Calibri" pitchFamily="34" charset="-122"/>
+                <a:cs typeface="Calibri" pitchFamily="34" charset="-120"/>
+              </a:rPr>
+              <a:t>Internal Use</a:t>
+            </a:r>
+            <a:endParaRPr lang="en-US" sz="900" dirty="0"/>
+          </a:p>
+        </p:txBody>
+      </p:sp>
+      <p:sp>
+        <p:nvSpPr>
+          <p:cNvPr id="5" name="Shape 3"/>
+          <p:cNvSpPr/>
+          <p:nvPr/>
+        </p:nvSpPr>
+        <p:spPr>
+          <a:xfrm>
             <a:off x="548640" y="1371600"/>
-            <a:ext cx="7680960" cy="2721178"/>
-          </a:xfrm>
-          <a:prstGeom prst="rect">
-            <a:avLst/>
-          </a:prstGeom>
-        </p:spPr>
-      </p:pic>
-      <p:sp>
-        <p:nvSpPr>
-          <p:cNvPr id="6" name="Shape 3"/>
-          <p:cNvSpPr/>
-          <p:nvPr/>
-        </p:nvSpPr>
-        <p:spPr>
-          <a:xfrm>
-            <a:off x="8503920" y="1371600"/>
-            <a:ext cx="3154680" cy="2721178"/>
+            <a:ext cx="5623560" cy="4297680"/>
           </a:xfrm>
           <a:prstGeom prst="roundRect">
             <a:avLst>
-              <a:gd name="adj" fmla="val 2016"/>
+              <a:gd name="adj" fmla="val 1064"/>
             </a:avLst>
           </a:prstGeom>
           <a:solidFill>
-            <a:srgbClr val="A8F0EE"/>
+            <a:srgbClr val="0E2A2A"/>
+          </a:solidFill>
+          <a:ln w="12700">
+            <a:solidFill>
+              <a:srgbClr val="0E2A2A"/>
+            </a:solidFill>
+            <a:prstDash val="solid"/>
+          </a:ln>
+        </p:spPr>
+      </p:sp>
+      <p:sp>
+        <p:nvSpPr>
+          <p:cNvPr id="6" name="Text 4"/>
+          <p:cNvSpPr/>
+          <p:nvPr/>
+        </p:nvSpPr>
+        <p:spPr>
+          <a:xfrm>
+            <a:off x="713232" y="1499616"/>
+            <a:ext cx="5294376" cy="4041648"/>
+          </a:xfrm>
+          <a:prstGeom prst="rect">
+            <a:avLst/>
+          </a:prstGeom>
+          <a:noFill/>
+          <a:ln/>
+        </p:spPr>
+        <p:txBody>
+          <a:bodyPr wrap="square" lIns="0" tIns="0" rIns="0" bIns="0" rtlCol="0" anchor="t"/>
+          <a:lstStyle/>
+          <a:p>
+            <a:pPr algn="l" indent="0" marL="0">
+              <a:lnSpc>
+                <a:spcPct val="105000"/>
+              </a:lnSpc>
+              <a:buNone/>
+            </a:pPr>
+            <a:r>
+              <a:rPr lang="en-US" sz="950" dirty="0">
+                <a:solidFill>
+                  <a:srgbClr val="CFE8E6"/>
+                </a:solidFill>
+                <a:latin typeface="Courier New" pitchFamily="34" charset="0"/>
+                <a:ea typeface="Courier New" pitchFamily="34" charset="-122"/>
+                <a:cs typeface="Courier New" pitchFamily="34" charset="-120"/>
+              </a:rPr>
+              <a:t>CREATE OR REPLACE DATABASE</a:t>
+            </a:r>
+            <a:endParaRPr lang="en-US" sz="950" dirty="0"/>
+          </a:p>
+          <a:p>
+            <a:pPr algn="l" indent="0" marL="0">
+              <a:lnSpc>
+                <a:spcPct val="105000"/>
+              </a:lnSpc>
+              <a:buNone/>
+            </a:pPr>
+            <a:r>
+              <a:rPr lang="en-US" sz="950" dirty="0">
+                <a:solidFill>
+                  <a:srgbClr val="CFE8E6"/>
+                </a:solidFill>
+                <a:latin typeface="Courier New" pitchFamily="34" charset="0"/>
+                <a:ea typeface="Courier New" pitchFamily="34" charset="-122"/>
+                <a:cs typeface="Courier New" pitchFamily="34" charset="-120"/>
+              </a:rPr>
+              <a:t>    shared_gcp_data</a:t>
+            </a:r>
+            <a:endParaRPr lang="en-US" sz="950" dirty="0"/>
+          </a:p>
+          <a:p>
+            <a:pPr algn="l" indent="0" marL="0">
+              <a:lnSpc>
+                <a:spcPct val="105000"/>
+              </a:lnSpc>
+              <a:buNone/>
+            </a:pPr>
+            <a:r>
+              <a:rPr lang="en-US" sz="950" dirty="0">
+                <a:solidFill>
+                  <a:srgbClr val="CFE8E6"/>
+                </a:solidFill>
+                <a:latin typeface="Courier New" pitchFamily="34" charset="0"/>
+                <a:ea typeface="Courier New" pitchFamily="34" charset="-122"/>
+                <a:cs typeface="Courier New" pitchFamily="34" charset="-120"/>
+              </a:rPr>
+              <a:t>  LINKED_CATALOG = (</a:t>
+            </a:r>
+            <a:endParaRPr lang="en-US" sz="950" dirty="0"/>
+          </a:p>
+          <a:p>
+            <a:pPr algn="l" indent="0" marL="0">
+              <a:lnSpc>
+                <a:spcPct val="105000"/>
+              </a:lnSpc>
+              <a:buNone/>
+            </a:pPr>
+            <a:r>
+              <a:rPr lang="en-US" sz="950" dirty="0">
+                <a:solidFill>
+                  <a:srgbClr val="CFE8E6"/>
+                </a:solidFill>
+                <a:latin typeface="Courier New" pitchFamily="34" charset="0"/>
+                <a:ea typeface="Courier New" pitchFamily="34" charset="-122"/>
+                <a:cs typeface="Courier New" pitchFamily="34" charset="-120"/>
+              </a:rPr>
+              <a:t>    CATALOG = 'biglake_int' );</a:t>
+            </a:r>
+            <a:endParaRPr lang="en-US" sz="950" dirty="0"/>
+          </a:p>
+          <a:p>
+            <a:pPr algn="l" indent="0" marL="0">
+              <a:lnSpc>
+                <a:spcPct val="105000"/>
+              </a:lnSpc>
+              <a:buNone/>
+            </a:pPr>
+            <a:endParaRPr lang="en-US" sz="950" dirty="0"/>
+          </a:p>
+          <a:p>
+            <a:pPr algn="l" indent="0" marL="0">
+              <a:lnSpc>
+                <a:spcPct val="105000"/>
+              </a:lnSpc>
+              <a:buNone/>
+            </a:pPr>
+            <a:r>
+              <a:rPr lang="en-US" sz="950" dirty="0">
+                <a:solidFill>
+                  <a:srgbClr val="CFE8E6"/>
+                </a:solidFill>
+                <a:latin typeface="Courier New" pitchFamily="34" charset="0"/>
+                <a:ea typeface="Courier New" pitchFamily="34" charset="-122"/>
+                <a:cs typeface="Courier New" pitchFamily="34" charset="-120"/>
+              </a:rPr>
+              <a:t>-- discovery is async; wait ~1 min</a:t>
+            </a:r>
+            <a:endParaRPr lang="en-US" sz="950" dirty="0"/>
+          </a:p>
+          <a:p>
+            <a:pPr algn="l" indent="0" marL="0">
+              <a:lnSpc>
+                <a:spcPct val="105000"/>
+              </a:lnSpc>
+              <a:buNone/>
+            </a:pPr>
+            <a:endParaRPr lang="en-US" sz="950" dirty="0"/>
+          </a:p>
+          <a:p>
+            <a:pPr algn="l" indent="0" marL="0">
+              <a:lnSpc>
+                <a:spcPct val="105000"/>
+              </a:lnSpc>
+              <a:buNone/>
+            </a:pPr>
+            <a:r>
+              <a:rPr lang="en-US" sz="950" dirty="0">
+                <a:solidFill>
+                  <a:srgbClr val="CFE8E6"/>
+                </a:solidFill>
+                <a:latin typeface="Courier New" pitchFamily="34" charset="0"/>
+                <a:ea typeface="Courier New" pitchFamily="34" charset="-122"/>
+                <a:cs typeface="Courier New" pitchFamily="34" charset="-120"/>
+              </a:rPr>
+              <a:t>SELECT *</a:t>
+            </a:r>
+            <a:endParaRPr lang="en-US" sz="950" dirty="0"/>
+          </a:p>
+          <a:p>
+            <a:pPr algn="l" indent="0" marL="0">
+              <a:lnSpc>
+                <a:spcPct val="105000"/>
+              </a:lnSpc>
+              <a:buNone/>
+            </a:pPr>
+            <a:r>
+              <a:rPr lang="en-US" sz="950" dirty="0">
+                <a:solidFill>
+                  <a:srgbClr val="CFE8E6"/>
+                </a:solidFill>
+                <a:latin typeface="Courier New" pitchFamily="34" charset="0"/>
+                <a:ea typeface="Courier New" pitchFamily="34" charset="-122"/>
+                <a:cs typeface="Courier New" pitchFamily="34" charset="-120"/>
+              </a:rPr>
+              <a:t>FROM   shared_gcp_data</a:t>
+            </a:r>
+            <a:endParaRPr lang="en-US" sz="950" dirty="0"/>
+          </a:p>
+          <a:p>
+            <a:pPr algn="l" indent="0" marL="0">
+              <a:lnSpc>
+                <a:spcPct val="105000"/>
+              </a:lnSpc>
+              <a:buNone/>
+            </a:pPr>
+            <a:r>
+              <a:rPr lang="en-US" sz="950" dirty="0">
+                <a:solidFill>
+                  <a:srgbClr val="CFE8E6"/>
+                </a:solidFill>
+                <a:latin typeface="Courier New" pitchFamily="34" charset="0"/>
+                <a:ea typeface="Courier New" pitchFamily="34" charset="-122"/>
+                <a:cs typeface="Courier New" pitchFamily="34" charset="-120"/>
+              </a:rPr>
+              <a:t>       .shared_aws.orders;</a:t>
+            </a:r>
+            <a:endParaRPr lang="en-US" sz="950" dirty="0"/>
+          </a:p>
+          <a:p>
+            <a:pPr algn="l" indent="0" marL="0">
+              <a:lnSpc>
+                <a:spcPct val="105000"/>
+              </a:lnSpc>
+              <a:buNone/>
+            </a:pPr>
+            <a:endParaRPr lang="en-US" sz="950" dirty="0"/>
+          </a:p>
+          <a:p>
+            <a:pPr algn="l" indent="0" marL="0">
+              <a:lnSpc>
+                <a:spcPct val="105000"/>
+              </a:lnSpc>
+              <a:buNone/>
+            </a:pPr>
+            <a:r>
+              <a:rPr lang="en-US" sz="950" dirty="0">
+                <a:solidFill>
+                  <a:srgbClr val="CFE8E6"/>
+                </a:solidFill>
+                <a:latin typeface="Courier New" pitchFamily="34" charset="0"/>
+                <a:ea typeface="Courier New" pitchFamily="34" charset="-122"/>
+                <a:cs typeface="Courier New" pitchFamily="34" charset="-120"/>
+              </a:rPr>
+              <a:t>-- rows back = zero-copy read works</a:t>
+            </a:r>
+            <a:endParaRPr lang="en-US" sz="950" dirty="0"/>
+          </a:p>
+        </p:txBody>
+      </p:sp>
+      <p:pic>
+        <p:nvPicPr>
+          <p:cNvPr id="7" name="Image 0" descr="C:/Users/jerem/Desktop/zc/data_zero_copy_snowflake_side.png">    </p:cNvPr>
+          <p:cNvPicPr>
+            <a:picLocks noChangeAspect="1"/>
+          </p:cNvPicPr>
+          <p:nvPr/>
+        </p:nvPicPr>
+        <p:blipFill>
+          <a:blip r:embed="rId1"/>
+          <a:stretch>
+            <a:fillRect/>
+          </a:stretch>
+        </p:blipFill>
+        <p:spPr>
+          <a:xfrm>
+            <a:off x="6355080" y="2199028"/>
+            <a:ext cx="5394960" cy="1911303"/>
+          </a:xfrm>
+          <a:prstGeom prst="rect">
+            <a:avLst/>
+          </a:prstGeom>
+        </p:spPr>
+      </p:pic>
+      <p:sp>
+        <p:nvSpPr>
+          <p:cNvPr id="8" name="Text 5"/>
+          <p:cNvSpPr/>
+          <p:nvPr/>
+        </p:nvSpPr>
+        <p:spPr>
+          <a:xfrm>
+            <a:off x="6355080" y="5074920"/>
+            <a:ext cx="5349240" cy="685800"/>
+          </a:xfrm>
+          <a:prstGeom prst="rect">
+            <a:avLst/>
+          </a:prstGeom>
+          <a:noFill/>
+          <a:ln/>
+        </p:spPr>
+        <p:txBody>
+          <a:bodyPr wrap="square" lIns="0" tIns="0" rIns="0" bIns="0" rtlCol="0" anchor="t"/>
+          <a:lstStyle/>
+          <a:p>
+            <a:pPr indent="0" marL="0">
+              <a:buNone/>
+            </a:pPr>
+            <a:r>
+              <a:rPr lang="en-US" sz="1150" i="1" dirty="0">
+                <a:solidFill>
+                  <a:srgbClr val="5B6B6B"/>
+                </a:solidFill>
+                <a:latin typeface="Calibri" pitchFamily="34" charset="0"/>
+                <a:ea typeface="Calibri" pitchFamily="34" charset="-122"/>
+                <a:cs typeface="Calibri" pitchFamily="34" charset="-120"/>
+              </a:rPr>
+              <a:t>A plain SELECT in Snowflake — GCS-resident data, read live, no copy.</a:t>
+            </a:r>
+            <a:endParaRPr lang="en-US" sz="1150" dirty="0"/>
+          </a:p>
+        </p:txBody>
+      </p:sp>
+    </p:spTree>
+  </p:cSld>
+  <p:clrMapOvr>
+    <a:masterClrMapping/>
+  </p:clrMapOvr>
+</p:sld>
+</file>
+
+<file path=ppt/slides/slide19.xml><?xml version="1.0" encoding="utf-8"?>
+<p:sld xmlns:a="http://schemas.openxmlformats.org/drawingml/2006/main" xmlns:r="http://schemas.openxmlformats.org/officeDocument/2006/relationships" xmlns:p="http://schemas.openxmlformats.org/presentationml/2006/main">
+  <p:cSld name="Slide 19">
+    <p:bg>
+      <p:bgPr>
+        <a:solidFill>
+          <a:srgbClr val="F4F4F3"/>
+        </a:solidFill>
+      </p:bgPr>
+    </p:bg>
+    <p:spTree>
+      <p:nvGrpSpPr>
+        <p:cNvPr id="1" name=""/>
+        <p:cNvGrpSpPr/>
+        <p:nvPr/>
+      </p:nvGrpSpPr>
+      <p:grpSpPr>
+        <a:xfrm>
+          <a:off x="0" y="0"/>
+          <a:ext cx="0" cy="0"/>
+          <a:chOff x="0" y="0"/>
+          <a:chExt cx="0" cy="0"/>
+        </a:xfrm>
+      </p:grpSpPr>
+      <p:sp>
+        <p:nvSpPr>
+          <p:cNvPr id="2" name="Text 0"/>
+          <p:cNvSpPr/>
+          <p:nvPr/>
+        </p:nvSpPr>
+        <p:spPr>
+          <a:xfrm>
+            <a:off x="548640" y="274320"/>
+            <a:ext cx="11064240" cy="502920"/>
+          </a:xfrm>
+          <a:prstGeom prst="rect">
+            <a:avLst/>
+          </a:prstGeom>
+          <a:noFill/>
+          <a:ln/>
+        </p:spPr>
+        <p:txBody>
+          <a:bodyPr wrap="square" lIns="0" tIns="0" rIns="0" bIns="0" rtlCol="0" anchor="ctr"/>
+          <a:lstStyle/>
+          <a:p>
+            <a:pPr algn="l" indent="0" marL="0">
+              <a:buNone/>
+            </a:pPr>
+            <a:r>
+              <a:rPr lang="en-US" sz="2800" dirty="0">
+                <a:solidFill>
+                  <a:srgbClr val="0F5C56"/>
+                </a:solidFill>
+                <a:latin typeface="Cambria" pitchFamily="34" charset="0"/>
+                <a:ea typeface="Cambria" pitchFamily="34" charset="-122"/>
+                <a:cs typeface="Cambria" pitchFamily="34" charset="-120"/>
+              </a:rPr>
+              <a:t>Appendix  ·  Sharp Edges</a:t>
+            </a:r>
+            <a:endParaRPr lang="en-US" sz="2800" dirty="0"/>
+          </a:p>
+        </p:txBody>
+      </p:sp>
+      <p:sp>
+        <p:nvSpPr>
+          <p:cNvPr id="3" name="Text 1"/>
+          <p:cNvSpPr/>
+          <p:nvPr/>
+        </p:nvSpPr>
+        <p:spPr>
+          <a:xfrm>
+            <a:off x="566928" y="749808"/>
+            <a:ext cx="11064240" cy="365760"/>
+          </a:xfrm>
+          <a:prstGeom prst="rect">
+            <a:avLst/>
+          </a:prstGeom>
+          <a:noFill/>
+          <a:ln/>
+        </p:spPr>
+        <p:txBody>
+          <a:bodyPr wrap="square" lIns="0" tIns="0" rIns="0" bIns="0" rtlCol="0" anchor="ctr"/>
+          <a:lstStyle/>
+          <a:p>
+            <a:pPr indent="0" marL="0">
+              <a:buNone/>
+            </a:pPr>
+            <a:r>
+              <a:rPr lang="en-US" sz="1400" i="1" dirty="0">
+                <a:solidFill>
+                  <a:srgbClr val="1A2E2E"/>
+                </a:solidFill>
+                <a:latin typeface="Calibri" pitchFamily="34" charset="0"/>
+                <a:ea typeface="Calibri" pitchFamily="34" charset="-122"/>
+                <a:cs typeface="Calibri" pitchFamily="34" charset="-120"/>
+              </a:rPr>
+              <a:t>The non-obvious failures we hit, so you don't</a:t>
+            </a:r>
+            <a:endParaRPr lang="en-US" sz="1400" dirty="0"/>
+          </a:p>
+        </p:txBody>
+      </p:sp>
+      <p:sp>
+        <p:nvSpPr>
+          <p:cNvPr id="4" name="Text 2"/>
+          <p:cNvSpPr/>
+          <p:nvPr/>
+        </p:nvSpPr>
+        <p:spPr>
+          <a:xfrm>
+            <a:off x="0" y="6583680"/>
+            <a:ext cx="12188952" cy="274320"/>
+          </a:xfrm>
+          <a:prstGeom prst="rect">
+            <a:avLst/>
+          </a:prstGeom>
+          <a:noFill/>
+          <a:ln/>
+        </p:spPr>
+        <p:txBody>
+          <a:bodyPr wrap="square" lIns="0" tIns="0" rIns="0" bIns="0" rtlCol="0" anchor="ctr"/>
+          <a:lstStyle/>
+          <a:p>
+            <a:pPr algn="ctr" indent="0" marL="0">
+              <a:buNone/>
+            </a:pPr>
+            <a:r>
+              <a:rPr lang="en-US" sz="900" dirty="0">
+                <a:solidFill>
+                  <a:srgbClr val="5B6B6B"/>
+                </a:solidFill>
+                <a:latin typeface="Calibri" pitchFamily="34" charset="0"/>
+                <a:ea typeface="Calibri" pitchFamily="34" charset="-122"/>
+                <a:cs typeface="Calibri" pitchFamily="34" charset="-120"/>
+              </a:rPr>
+              <a:t>Internal Use</a:t>
+            </a:r>
+            <a:endParaRPr lang="en-US" sz="900" dirty="0"/>
+          </a:p>
+        </p:txBody>
+      </p:sp>
+      <p:sp>
+        <p:nvSpPr>
+          <p:cNvPr id="5" name="Shape 3"/>
+          <p:cNvSpPr/>
+          <p:nvPr/>
+        </p:nvSpPr>
+        <p:spPr>
+          <a:xfrm>
+            <a:off x="548640" y="1371600"/>
+            <a:ext cx="11109960" cy="4023360"/>
+          </a:xfrm>
+          <a:prstGeom prst="roundRect">
+            <a:avLst>
+              <a:gd name="adj" fmla="val 1364"/>
+            </a:avLst>
+          </a:prstGeom>
+          <a:solidFill>
+            <a:srgbClr val="FFFFFF"/>
           </a:solidFill>
           <a:ln w="17780">
             <a:solidFill>
-              <a:srgbClr val="6FBFB8"/>
+              <a:srgbClr val="D8D8D6"/>
             </a:solidFill>
             <a:prstDash val="solid"/>
           </a:ln>
@@ -6467,30 +7518,94 @@
       </p:sp>
       <p:sp>
         <p:nvSpPr>
-          <p:cNvPr id="7" name="Text 4"/>
-          <p:cNvSpPr/>
-          <p:nvPr/>
-        </p:nvSpPr>
-        <p:spPr>
-          <a:xfrm>
-            <a:off x="8732520" y="1371600"/>
-            <a:ext cx="2697480" cy="2721178"/>
-          </a:xfrm>
-          <a:prstGeom prst="rect">
-            <a:avLst/>
-          </a:prstGeom>
-          <a:noFill/>
-          <a:ln/>
-        </p:spPr>
-        <p:txBody>
-          <a:bodyPr wrap="square" lIns="1270" tIns="1270" rIns="1270" bIns="1270" rtlCol="0" anchor="ctr"/>
+          <p:cNvPr id="6" name="Shape 4"/>
+          <p:cNvSpPr/>
+          <p:nvPr/>
+        </p:nvSpPr>
+        <p:spPr>
+          <a:xfrm>
+            <a:off x="822960" y="1591056"/>
+            <a:ext cx="365760" cy="365760"/>
+          </a:xfrm>
+          <a:prstGeom prst="ellipse">
+            <a:avLst/>
+          </a:prstGeom>
+          <a:solidFill>
+            <a:srgbClr val="C1502E"/>
+          </a:solidFill>
+          <a:ln w="12700">
+            <a:solidFill>
+              <a:srgbClr val="C1502E"/>
+            </a:solidFill>
+            <a:prstDash val="solid"/>
+          </a:ln>
+        </p:spPr>
+      </p:sp>
+      <p:sp>
+        <p:nvSpPr>
+          <p:cNvPr id="7" name="Text 5"/>
+          <p:cNvSpPr/>
+          <p:nvPr/>
+        </p:nvSpPr>
+        <p:spPr>
+          <a:xfrm>
+            <a:off x="822960" y="1591056"/>
+            <a:ext cx="365760" cy="365760"/>
+          </a:xfrm>
+          <a:prstGeom prst="rect">
+            <a:avLst/>
+          </a:prstGeom>
+          <a:noFill/>
+          <a:ln/>
+        </p:spPr>
+        <p:txBody>
+          <a:bodyPr wrap="square" lIns="0" tIns="0" rIns="0" bIns="0" rtlCol="0" anchor="ctr"/>
+          <a:lstStyle/>
+          <a:p>
+            <a:pPr algn="ctr" indent="0" marL="0">
+              <a:buNone/>
+            </a:pPr>
+            <a:r>
+              <a:rPr lang="en-US" sz="1200" b="1" dirty="0">
+                <a:solidFill>
+                  <a:srgbClr val="FFFFFF"/>
+                </a:solidFill>
+                <a:latin typeface="Cambria" pitchFamily="34" charset="0"/>
+                <a:ea typeface="Cambria" pitchFamily="34" charset="-122"/>
+                <a:cs typeface="Cambria" pitchFamily="34" charset="-120"/>
+              </a:rPr>
+              <a:t>1</a:t>
+            </a:r>
+            <a:endParaRPr lang="en-US" sz="1200" dirty="0"/>
+          </a:p>
+        </p:txBody>
+      </p:sp>
+      <p:sp>
+        <p:nvSpPr>
+          <p:cNvPr id="8" name="Text 6"/>
+          <p:cNvSpPr/>
+          <p:nvPr/>
+        </p:nvSpPr>
+        <p:spPr>
+          <a:xfrm>
+            <a:off x="1371600" y="1527048"/>
+            <a:ext cx="10058400" cy="713232"/>
+          </a:xfrm>
+          <a:prstGeom prst="rect">
+            <a:avLst/>
+          </a:prstGeom>
+          <a:noFill/>
+          <a:ln/>
+        </p:spPr>
+        <p:txBody>
+          <a:bodyPr wrap="square" lIns="0" tIns="0" rIns="0" bIns="0" rtlCol="0" anchor="t"/>
           <a:lstStyle/>
           <a:p>
             <a:pPr indent="0" marL="0">
               <a:buNone/>
             </a:pPr>
             <a:r>
-              <a:rPr lang="en-US" sz="1400" b="1" dirty="0">
+              <a:rPr lang="en-US" sz="1250" b="1" dirty="0">
                 <a:solidFill>
                   <a:srgbClr val="0B3D3D"/>
                 </a:solidFill>
@@ -6498,12 +7613,8 @@
                 <a:ea typeface="Calibri" pitchFamily="34" charset="-122"/>
                 <a:cs typeface="Calibri" pitchFamily="34" charset="-120"/>
               </a:rPr>
-              <a:t>No pipeline. No copy.
-</a:t>
-            </a:r>
-            <a:endParaRPr lang="en-US" sz="1400" dirty="0"/>
-          </a:p>
-          <a:p>
+              <a:t>Runtime SA storage grant is NOT automatic   </a:t>
+            </a:r>
             <a:pPr indent="0" marL="0">
               <a:buNone/>
             </a:pPr>
@@ -6516,9 +7627,477 @@
                 <a:ea typeface="Calibri" pitchFamily="34" charset="-122"/>
                 <a:cs typeface="Calibri" pitchFamily="34" charset="-120"/>
               </a:rPr>
-              <a:t>The fourth row was inserted on the GCP side and appeared in the next query with nothing running in between — the freshness proof.</a:t>
-            </a:r>
-            <a:endParaRPr lang="en-US" sz="1400" dirty="0"/>
+              <a:t>The catalog's auto-provisioned service account needs an explicit storage.objectUser grant on the bucket, or vending fails.</a:t>
+            </a:r>
+            <a:endParaRPr lang="en-US" sz="1250" dirty="0"/>
+          </a:p>
+        </p:txBody>
+      </p:sp>
+      <p:sp>
+        <p:nvSpPr>
+          <p:cNvPr id="9" name="Shape 7"/>
+          <p:cNvSpPr/>
+          <p:nvPr/>
+        </p:nvSpPr>
+        <p:spPr>
+          <a:xfrm>
+            <a:off x="822960" y="2350008"/>
+            <a:ext cx="365760" cy="365760"/>
+          </a:xfrm>
+          <a:prstGeom prst="ellipse">
+            <a:avLst/>
+          </a:prstGeom>
+          <a:solidFill>
+            <a:srgbClr val="C1502E"/>
+          </a:solidFill>
+          <a:ln w="12700">
+            <a:solidFill>
+              <a:srgbClr val="C1502E"/>
+            </a:solidFill>
+            <a:prstDash val="solid"/>
+          </a:ln>
+        </p:spPr>
+      </p:sp>
+      <p:sp>
+        <p:nvSpPr>
+          <p:cNvPr id="10" name="Text 8"/>
+          <p:cNvSpPr/>
+          <p:nvPr/>
+        </p:nvSpPr>
+        <p:spPr>
+          <a:xfrm>
+            <a:off x="822960" y="2350008"/>
+            <a:ext cx="365760" cy="365760"/>
+          </a:xfrm>
+          <a:prstGeom prst="rect">
+            <a:avLst/>
+          </a:prstGeom>
+          <a:noFill/>
+          <a:ln/>
+        </p:spPr>
+        <p:txBody>
+          <a:bodyPr wrap="square" lIns="0" tIns="0" rIns="0" bIns="0" rtlCol="0" anchor="ctr"/>
+          <a:lstStyle/>
+          <a:p>
+            <a:pPr algn="ctr" indent="0" marL="0">
+              <a:buNone/>
+            </a:pPr>
+            <a:r>
+              <a:rPr lang="en-US" sz="1200" b="1" dirty="0">
+                <a:solidFill>
+                  <a:srgbClr val="FFFFFF"/>
+                </a:solidFill>
+                <a:latin typeface="Cambria" pitchFamily="34" charset="0"/>
+                <a:ea typeface="Cambria" pitchFamily="34" charset="-122"/>
+                <a:cs typeface="Cambria" pitchFamily="34" charset="-120"/>
+              </a:rPr>
+              <a:t>2</a:t>
+            </a:r>
+            <a:endParaRPr lang="en-US" sz="1200" dirty="0"/>
+          </a:p>
+        </p:txBody>
+      </p:sp>
+      <p:sp>
+        <p:nvSpPr>
+          <p:cNvPr id="11" name="Text 9"/>
+          <p:cNvSpPr/>
+          <p:nvPr/>
+        </p:nvSpPr>
+        <p:spPr>
+          <a:xfrm>
+            <a:off x="1371600" y="2286000"/>
+            <a:ext cx="10058400" cy="713232"/>
+          </a:xfrm>
+          <a:prstGeom prst="rect">
+            <a:avLst/>
+          </a:prstGeom>
+          <a:noFill/>
+          <a:ln/>
+        </p:spPr>
+        <p:txBody>
+          <a:bodyPr wrap="square" lIns="0" tIns="0" rIns="0" bIns="0" rtlCol="0" anchor="t"/>
+          <a:lstStyle/>
+          <a:p>
+            <a:pPr indent="0" marL="0">
+              <a:buNone/>
+            </a:pPr>
+            <a:r>
+              <a:rPr lang="en-US" sz="1250" b="1" dirty="0">
+                <a:solidFill>
+                  <a:srgbClr val="0B3D3D"/>
+                </a:solidFill>
+                <a:latin typeface="Calibri" pitchFamily="34" charset="0"/>
+                <a:ea typeface="Calibri" pitchFamily="34" charset="-122"/>
+                <a:cs typeface="Calibri" pitchFamily="34" charset="-120"/>
+              </a:rPr>
+              <a:t>The Snowflake principal needs more than read   </a:t>
+            </a:r>
+            <a:pPr indent="0" marL="0">
+              <a:buNone/>
+            </a:pPr>
+            <a:r>
+              <a:rPr lang="en-US" sz="1250" dirty="0">
+                <a:solidFill>
+                  <a:srgbClr val="1A2E2E"/>
+                </a:solidFill>
+                <a:latin typeface="Calibri" pitchFamily="34" charset="0"/>
+                <a:ea typeface="Calibri" pitchFamily="34" charset="-122"/>
+                <a:cs typeface="Calibri" pitchFamily="34" charset="-120"/>
+              </a:rPr>
+              <a:t>It also needs rights to use the project's billed APIs (serviceusage.serviceUsageConsumer) for the x-goog-user-project header.</a:t>
+            </a:r>
+            <a:endParaRPr lang="en-US" sz="1250" dirty="0"/>
+          </a:p>
+        </p:txBody>
+      </p:sp>
+      <p:sp>
+        <p:nvSpPr>
+          <p:cNvPr id="12" name="Shape 10"/>
+          <p:cNvSpPr/>
+          <p:nvPr/>
+        </p:nvSpPr>
+        <p:spPr>
+          <a:xfrm>
+            <a:off x="822960" y="3108960"/>
+            <a:ext cx="365760" cy="365760"/>
+          </a:xfrm>
+          <a:prstGeom prst="ellipse">
+            <a:avLst/>
+          </a:prstGeom>
+          <a:solidFill>
+            <a:srgbClr val="C1502E"/>
+          </a:solidFill>
+          <a:ln w="12700">
+            <a:solidFill>
+              <a:srgbClr val="C1502E"/>
+            </a:solidFill>
+            <a:prstDash val="solid"/>
+          </a:ln>
+        </p:spPr>
+      </p:sp>
+      <p:sp>
+        <p:nvSpPr>
+          <p:cNvPr id="13" name="Text 11"/>
+          <p:cNvSpPr/>
+          <p:nvPr/>
+        </p:nvSpPr>
+        <p:spPr>
+          <a:xfrm>
+            <a:off x="822960" y="3108960"/>
+            <a:ext cx="365760" cy="365760"/>
+          </a:xfrm>
+          <a:prstGeom prst="rect">
+            <a:avLst/>
+          </a:prstGeom>
+          <a:noFill/>
+          <a:ln/>
+        </p:spPr>
+        <p:txBody>
+          <a:bodyPr wrap="square" lIns="0" tIns="0" rIns="0" bIns="0" rtlCol="0" anchor="ctr"/>
+          <a:lstStyle/>
+          <a:p>
+            <a:pPr algn="ctr" indent="0" marL="0">
+              <a:buNone/>
+            </a:pPr>
+            <a:r>
+              <a:rPr lang="en-US" sz="1200" b="1" dirty="0">
+                <a:solidFill>
+                  <a:srgbClr val="FFFFFF"/>
+                </a:solidFill>
+                <a:latin typeface="Cambria" pitchFamily="34" charset="0"/>
+                <a:ea typeface="Cambria" pitchFamily="34" charset="-122"/>
+                <a:cs typeface="Cambria" pitchFamily="34" charset="-120"/>
+              </a:rPr>
+              <a:t>3</a:t>
+            </a:r>
+            <a:endParaRPr lang="en-US" sz="1200" dirty="0"/>
+          </a:p>
+        </p:txBody>
+      </p:sp>
+      <p:sp>
+        <p:nvSpPr>
+          <p:cNvPr id="14" name="Text 12"/>
+          <p:cNvSpPr/>
+          <p:nvPr/>
+        </p:nvSpPr>
+        <p:spPr>
+          <a:xfrm>
+            <a:off x="1371600" y="3044952"/>
+            <a:ext cx="10058400" cy="713232"/>
+          </a:xfrm>
+          <a:prstGeom prst="rect">
+            <a:avLst/>
+          </a:prstGeom>
+          <a:noFill/>
+          <a:ln/>
+        </p:spPr>
+        <p:txBody>
+          <a:bodyPr wrap="square" lIns="0" tIns="0" rIns="0" bIns="0" rtlCol="0" anchor="t"/>
+          <a:lstStyle/>
+          <a:p>
+            <a:pPr indent="0" marL="0">
+              <a:buNone/>
+            </a:pPr>
+            <a:r>
+              <a:rPr lang="en-US" sz="1250" b="1" dirty="0">
+                <a:solidFill>
+                  <a:srgbClr val="0B3D3D"/>
+                </a:solidFill>
+                <a:latin typeface="Calibri" pitchFamily="34" charset="0"/>
+                <a:ea typeface="Calibri" pitchFamily="34" charset="-122"/>
+                <a:cs typeface="Calibri" pitchFamily="34" charset="-120"/>
+              </a:rPr>
+              <a:t>CREATE OR REPLACE mints a NEW trust subject   </a:t>
+            </a:r>
+            <a:pPr indent="0" marL="0">
+              <a:buNone/>
+            </a:pPr>
+            <a:r>
+              <a:rPr lang="en-US" sz="1250" dirty="0">
+                <a:solidFill>
+                  <a:srgbClr val="1A2E2E"/>
+                </a:solidFill>
+                <a:latin typeface="Calibri" pitchFamily="34" charset="0"/>
+                <a:ea typeface="Calibri" pitchFamily="34" charset="-122"/>
+                <a:cs typeface="Calibri" pitchFamily="34" charset="-120"/>
+              </a:rPr>
+              <a:t>Any replace of the catalog integration invalidates prior IAM grants — re-grant the new subject and remove the old.</a:t>
+            </a:r>
+            <a:endParaRPr lang="en-US" sz="1250" dirty="0"/>
+          </a:p>
+        </p:txBody>
+      </p:sp>
+      <p:sp>
+        <p:nvSpPr>
+          <p:cNvPr id="15" name="Shape 13"/>
+          <p:cNvSpPr/>
+          <p:nvPr/>
+        </p:nvSpPr>
+        <p:spPr>
+          <a:xfrm>
+            <a:off x="822960" y="3867912"/>
+            <a:ext cx="365760" cy="365760"/>
+          </a:xfrm>
+          <a:prstGeom prst="ellipse">
+            <a:avLst/>
+          </a:prstGeom>
+          <a:solidFill>
+            <a:srgbClr val="C1502E"/>
+          </a:solidFill>
+          <a:ln w="12700">
+            <a:solidFill>
+              <a:srgbClr val="C1502E"/>
+            </a:solidFill>
+            <a:prstDash val="solid"/>
+          </a:ln>
+        </p:spPr>
+      </p:sp>
+      <p:sp>
+        <p:nvSpPr>
+          <p:cNvPr id="16" name="Text 14"/>
+          <p:cNvSpPr/>
+          <p:nvPr/>
+        </p:nvSpPr>
+        <p:spPr>
+          <a:xfrm>
+            <a:off x="822960" y="3867912"/>
+            <a:ext cx="365760" cy="365760"/>
+          </a:xfrm>
+          <a:prstGeom prst="rect">
+            <a:avLst/>
+          </a:prstGeom>
+          <a:noFill/>
+          <a:ln/>
+        </p:spPr>
+        <p:txBody>
+          <a:bodyPr wrap="square" lIns="0" tIns="0" rIns="0" bIns="0" rtlCol="0" anchor="ctr"/>
+          <a:lstStyle/>
+          <a:p>
+            <a:pPr algn="ctr" indent="0" marL="0">
+              <a:buNone/>
+            </a:pPr>
+            <a:r>
+              <a:rPr lang="en-US" sz="1200" b="1" dirty="0">
+                <a:solidFill>
+                  <a:srgbClr val="FFFFFF"/>
+                </a:solidFill>
+                <a:latin typeface="Cambria" pitchFamily="34" charset="0"/>
+                <a:ea typeface="Cambria" pitchFamily="34" charset="-122"/>
+                <a:cs typeface="Cambria" pitchFamily="34" charset="-120"/>
+              </a:rPr>
+              <a:t>4</a:t>
+            </a:r>
+            <a:endParaRPr lang="en-US" sz="1200" dirty="0"/>
+          </a:p>
+        </p:txBody>
+      </p:sp>
+      <p:sp>
+        <p:nvSpPr>
+          <p:cNvPr id="17" name="Text 15"/>
+          <p:cNvSpPr/>
+          <p:nvPr/>
+        </p:nvSpPr>
+        <p:spPr>
+          <a:xfrm>
+            <a:off x="1371600" y="3803904"/>
+            <a:ext cx="10058400" cy="713232"/>
+          </a:xfrm>
+          <a:prstGeom prst="rect">
+            <a:avLst/>
+          </a:prstGeom>
+          <a:noFill/>
+          <a:ln/>
+        </p:spPr>
+        <p:txBody>
+          <a:bodyPr wrap="square" lIns="0" tIns="0" rIns="0" bIns="0" rtlCol="0" anchor="t"/>
+          <a:lstStyle/>
+          <a:p>
+            <a:pPr indent="0" marL="0">
+              <a:buNone/>
+            </a:pPr>
+            <a:r>
+              <a:rPr lang="en-US" sz="1250" b="1" dirty="0">
+                <a:solidFill>
+                  <a:srgbClr val="0B3D3D"/>
+                </a:solidFill>
+                <a:latin typeface="Calibri" pitchFamily="34" charset="0"/>
+                <a:ea typeface="Calibri" pitchFamily="34" charset="-122"/>
+                <a:cs typeface="Calibri" pitchFamily="34" charset="-120"/>
+              </a:rPr>
+              <a:t>Vended credentials must be explicitly enabled   </a:t>
+            </a:r>
+            <a:pPr indent="0" marL="0">
+              <a:buNone/>
+            </a:pPr>
+            <a:r>
+              <a:rPr lang="en-US" sz="1250" dirty="0">
+                <a:solidFill>
+                  <a:srgbClr val="1A2E2E"/>
+                </a:solidFill>
+                <a:latin typeface="Calibri" pitchFamily="34" charset="0"/>
+                <a:ea typeface="Calibri" pitchFamily="34" charset="-122"/>
+                <a:cs typeface="Calibri" pitchFamily="34" charset="-120"/>
+              </a:rPr>
+              <a:t>Without ACCESS_DELEGATION_MODE = VENDED_CREDENTIALS the catalog-linked database refuses to create.</a:t>
+            </a:r>
+            <a:endParaRPr lang="en-US" sz="1250" dirty="0"/>
+          </a:p>
+        </p:txBody>
+      </p:sp>
+      <p:sp>
+        <p:nvSpPr>
+          <p:cNvPr id="18" name="Shape 16"/>
+          <p:cNvSpPr/>
+          <p:nvPr/>
+        </p:nvSpPr>
+        <p:spPr>
+          <a:xfrm>
+            <a:off x="822960" y="4626864"/>
+            <a:ext cx="365760" cy="365760"/>
+          </a:xfrm>
+          <a:prstGeom prst="ellipse">
+            <a:avLst/>
+          </a:prstGeom>
+          <a:solidFill>
+            <a:srgbClr val="C1502E"/>
+          </a:solidFill>
+          <a:ln w="12700">
+            <a:solidFill>
+              <a:srgbClr val="C1502E"/>
+            </a:solidFill>
+            <a:prstDash val="solid"/>
+          </a:ln>
+        </p:spPr>
+      </p:sp>
+      <p:sp>
+        <p:nvSpPr>
+          <p:cNvPr id="19" name="Text 17"/>
+          <p:cNvSpPr/>
+          <p:nvPr/>
+        </p:nvSpPr>
+        <p:spPr>
+          <a:xfrm>
+            <a:off x="822960" y="4626864"/>
+            <a:ext cx="365760" cy="365760"/>
+          </a:xfrm>
+          <a:prstGeom prst="rect">
+            <a:avLst/>
+          </a:prstGeom>
+          <a:noFill/>
+          <a:ln/>
+        </p:spPr>
+        <p:txBody>
+          <a:bodyPr wrap="square" lIns="0" tIns="0" rIns="0" bIns="0" rtlCol="0" anchor="ctr"/>
+          <a:lstStyle/>
+          <a:p>
+            <a:pPr algn="ctr" indent="0" marL="0">
+              <a:buNone/>
+            </a:pPr>
+            <a:r>
+              <a:rPr lang="en-US" sz="1200" b="1" dirty="0">
+                <a:solidFill>
+                  <a:srgbClr val="FFFFFF"/>
+                </a:solidFill>
+                <a:latin typeface="Cambria" pitchFamily="34" charset="0"/>
+                <a:ea typeface="Cambria" pitchFamily="34" charset="-122"/>
+                <a:cs typeface="Cambria" pitchFamily="34" charset="-120"/>
+              </a:rPr>
+              <a:t>5</a:t>
+            </a:r>
+            <a:endParaRPr lang="en-US" sz="1200" dirty="0"/>
+          </a:p>
+        </p:txBody>
+      </p:sp>
+      <p:sp>
+        <p:nvSpPr>
+          <p:cNvPr id="20" name="Text 18"/>
+          <p:cNvSpPr/>
+          <p:nvPr/>
+        </p:nvSpPr>
+        <p:spPr>
+          <a:xfrm>
+            <a:off x="1371600" y="4562856"/>
+            <a:ext cx="10058400" cy="713232"/>
+          </a:xfrm>
+          <a:prstGeom prst="rect">
+            <a:avLst/>
+          </a:prstGeom>
+          <a:noFill/>
+          <a:ln/>
+        </p:spPr>
+        <p:txBody>
+          <a:bodyPr wrap="square" lIns="0" tIns="0" rIns="0" bIns="0" rtlCol="0" anchor="t"/>
+          <a:lstStyle/>
+          <a:p>
+            <a:pPr indent="0" marL="0">
+              <a:buNone/>
+            </a:pPr>
+            <a:r>
+              <a:rPr lang="en-US" sz="1250" b="1" dirty="0">
+                <a:solidFill>
+                  <a:srgbClr val="0B3D3D"/>
+                </a:solidFill>
+                <a:latin typeface="Calibri" pitchFamily="34" charset="0"/>
+                <a:ea typeface="Calibri" pitchFamily="34" charset="-122"/>
+                <a:cs typeface="Calibri" pitchFamily="34" charset="-120"/>
+              </a:rPr>
+              <a:t>Discovery is asynchronous   </a:t>
+            </a:r>
+            <a:pPr indent="0" marL="0">
+              <a:buNone/>
+            </a:pPr>
+            <a:r>
+              <a:rPr lang="en-US" sz="1250" dirty="0">
+                <a:solidFill>
+                  <a:srgbClr val="1A2E2E"/>
+                </a:solidFill>
+                <a:latin typeface="Calibri" pitchFamily="34" charset="0"/>
+                <a:ea typeface="Calibri" pitchFamily="34" charset="-122"/>
+                <a:cs typeface="Calibri" pitchFamily="34" charset="-120"/>
+              </a:rPr>
+              <a:t>The schema does not appear the instant the linked database is created — give it about a minute.</a:t>
+            </a:r>
+            <a:endParaRPr lang="en-US" sz="1250" dirty="0"/>
           </a:p>
         </p:txBody>
       </p:sp>

</xml_diff>